<commit_message>
Ibdaa board v2: English acronym title over Arabic, tagline, engineering drawing (pipeline + two protection layers), experimental groups incl. control, load notebook, KPI band and repo QR
Co-Authored-By: Claude Opus 5.5 <noreply@anthropic.com>
Claude-Session: https://claude.ai/code/session_013B4LPWZWgdrx1XoL9LPLxx
</commit_message>
<xml_diff>
--- a/docs/qacrs/board/ACRS_board.pptx
+++ b/docs/qacrs/board/ACRS_board.pptx
@@ -2683,8 +2683,8 @@
         </p:nvSpPr>
         <p:spPr>
           <a:xfrm>
-            <a:off x="2428875" y="3429000"/>
-            <a:ext cx="7639050" cy="857250"/>
+            <a:off x="2428875" y="2930000"/>
+            <a:ext cx="7639050" cy="1380000"/>
           </a:xfrm>
           <a:prstGeom prst="rect">
             <a:avLst/>
@@ -2712,7 +2712,7 @@
             </a:defPPr>
           </a:lstStyle>
           <a:p>
-            <a:pPr algn="ctr" rtl="1">
+            <a:pPr algn="ctr" rtl="0">
               <a:defRPr sz="4200" b="1">
                 <a:solidFill>
                   <a:srgbClr val="FFFFFF"/>
@@ -2723,15 +2723,38 @@
               </a:defRPr>
             </a:pPr>
             <a:r>
-              <a:rPr lang="ar-SA" sz="2900" b="1" dirty="0">
+              <a:rPr sz="4000" b="1">
                 <a:solidFill>
                   <a:srgbClr val="FFFFFF"/>
                 </a:solidFill>
                 <a:latin typeface="Arial"/>
-                <a:ea typeface="Arial"/>
-                <a:cs typeface="Arial"/>
-              </a:rPr>
-              <a:t>ACRS: احتواء الهجوم بأقل إجراء آمن</a:t>
+              </a:rPr>
+              <a:t>ACRS</a:t>
+            </a:r>
+            <a:r>
+              <a:rPr sz="2200" b="1">
+                <a:solidFill>
+                  <a:srgbClr val="FFFFFF"/>
+                </a:solidFill>
+                <a:latin typeface="Arial"/>
+              </a:rPr>
+              <a:t>  Automated Compromise Response System</a:t>
+            </a:r>
+          </a:p>
+          <a:p>
+            <a:pPr algn="ctr" rtl="1">
+              <a:spcBef>
+                <a:spcPts val="400"/>
+              </a:spcBef>
+            </a:pPr>
+            <a:r>
+              <a:rPr sz="2800" b="1">
+                <a:solidFill>
+                  <a:srgbClr val="FFFFFF"/>
+                </a:solidFill>
+                <a:latin typeface="Arial"/>
+              </a:rPr>
+              <a:t>نظام الاستجابة الآلية للاختراق</a:t>
             </a:r>
           </a:p>
         </p:txBody>
@@ -2752,7 +2775,7 @@
         </p:nvSpPr>
         <p:spPr>
           <a:xfrm>
-            <a:off x="6619875" y="4476750"/>
+            <a:off x="6619875" y="4420000"/>
             <a:ext cx="3143250" cy="457200"/>
           </a:xfrm>
           <a:prstGeom prst="rect">
@@ -2821,7 +2844,7 @@
         </p:nvSpPr>
         <p:spPr>
           <a:xfrm>
-            <a:off x="2762250" y="4476750"/>
+            <a:off x="2762250" y="4420000"/>
             <a:ext cx="3143250" cy="457200"/>
           </a:xfrm>
           <a:prstGeom prst="rect">
@@ -3270,7 +3293,7 @@
           <a:p>
             <a:pPr algn="r" rtl="1">
               <a:spcAft>
-                <a:spcPts val="300"/>
+                <a:spcPts val="100"/>
               </a:spcAft>
               <a:defRPr sz="1500" b="0">
                 <a:solidFill>
@@ -3282,115 +3305,105 @@
               </a:defRPr>
             </a:pPr>
             <a:r>
-              <a:rPr sz="1300" b="1" lang="ar-SA">
+              <a:rPr sz="1500" b="1" lang="ar-SA">
                 <a:solidFill>
                   <a:srgbClr val="008A58"/>
                 </a:solidFill>
                 <a:latin typeface="Arial"/>
                 <a:cs typeface="Arial"/>
               </a:rPr>
-              <a:t>91%</a:t>
-            </a:r>
-            <a:r>
-              <a:rPr sz="1300" b="0" lang="ar-SA">
+              <a:t>91%  </a:t>
+            </a:r>
+            <a:r>
+              <a:rPr sz="1200" b="0" lang="ar-SA">
                 <a:solidFill>
                   <a:srgbClr val="1C2328"/>
                 </a:solidFill>
                 <a:latin typeface="Arial"/>
                 <a:cs typeface="Arial"/>
               </a:rPr>
-              <a:t> احتواء تلقائي (75 حادثة جديدة)</a:t>
+              <a:t>احتواء تلقائي</a:t>
             </a:r>
           </a:p>
           <a:p>
             <a:pPr algn="r" rtl="1">
               <a:spcAft>
-                <a:spcPts val="300"/>
+                <a:spcPts val="100"/>
               </a:spcAft>
             </a:pPr>
             <a:r>
-              <a:rPr sz="1300" b="1" lang="ar-SA">
+              <a:rPr sz="1500" b="1" lang="ar-SA">
                 <a:solidFill>
                   <a:srgbClr val="008A58"/>
                 </a:solidFill>
                 <a:latin typeface="Arial"/>
                 <a:cs typeface="Arial"/>
               </a:rPr>
-              <a:t>70</a:t>
-            </a:r>
-            <a:r>
-              <a:rPr sz="1300" b="0" lang="ar-SA">
+              <a:t>70  </a:t>
+            </a:r>
+            <a:r>
+              <a:rPr sz="1200" b="0" lang="ar-SA">
                 <a:solidFill>
                   <a:srgbClr val="1C2328"/>
                 </a:solidFill>
                 <a:latin typeface="Arial"/>
                 <a:cs typeface="Arial"/>
               </a:rPr>
-              <a:t> خدمة متوقفة مقابل </a:t>
-            </a:r>
-            <a:r>
-              <a:rPr sz="1300" b="1" lang="ar-SA">
+              <a:t>خدمة متوقفة مقابل 268</a:t>
+            </a:r>
+          </a:p>
+          <a:p>
+            <a:pPr algn="r" rtl="1">
+              <a:spcAft>
+                <a:spcPts val="100"/>
+              </a:spcAft>
+            </a:pPr>
+            <a:r>
+              <a:rPr sz="1500" b="1" lang="ar-SA">
+                <a:solidFill>
+                  <a:srgbClr val="008A58"/>
+                </a:solidFill>
+                <a:latin typeface="Arial"/>
+                <a:cs typeface="Arial"/>
+              </a:rPr>
+              <a:t>0  </a:t>
+            </a:r>
+            <a:r>
+              <a:rPr sz="1200" b="0" lang="ar-SA">
                 <a:solidFill>
                   <a:srgbClr val="1C2328"/>
                 </a:solidFill>
                 <a:latin typeface="Arial"/>
                 <a:cs typeface="Arial"/>
               </a:rPr>
-              <a:t>268</a:t>
+              <a:t>قرارات غير آمنة</a:t>
             </a:r>
           </a:p>
           <a:p>
             <a:pPr algn="r" rtl="1">
               <a:spcAft>
-                <a:spcPts val="300"/>
+                <a:spcPts val="100"/>
               </a:spcAft>
             </a:pPr>
             <a:r>
-              <a:rPr sz="1300" b="1" lang="ar-SA">
+              <a:rPr sz="1500" b="1" lang="ar-SA">
                 <a:solidFill>
                   <a:srgbClr val="008A58"/>
                 </a:solidFill>
                 <a:latin typeface="Arial"/>
                 <a:cs typeface="Arial"/>
               </a:rPr>
-              <a:t>0</a:t>
-            </a:r>
-            <a:r>
-              <a:rPr sz="1300" b="0" lang="ar-SA">
+              <a:t>11/11  </a:t>
+            </a:r>
+            <a:r>
+              <a:rPr sz="1200" b="0" lang="ar-SA">
                 <a:solidFill>
                   <a:srgbClr val="1C2328"/>
                 </a:solidFill>
                 <a:latin typeface="Arial"/>
                 <a:cs typeface="Arial"/>
               </a:rPr>
-              <a:t> قرارات غير آمنة</a:t>
-            </a:r>
-          </a:p>
-          <a:p>
-            <a:pPr algn="r" rtl="1">
-              <a:spcAft>
-                <a:spcPts val="300"/>
-              </a:spcAft>
-            </a:pPr>
-            <a:r>
-              <a:rPr sz="1300" b="1" lang="ar-SA">
-                <a:solidFill>
-                  <a:srgbClr val="008A58"/>
-                </a:solidFill>
-                <a:latin typeface="Arial"/>
-                <a:cs typeface="Arial"/>
-              </a:rPr>
-              <a:t>11/11</a:t>
-            </a:r>
-            <a:r>
-              <a:rPr sz="1300" b="0" lang="ar-SA">
-                <a:solidFill>
-                  <a:srgbClr val="1C2328"/>
-                </a:solidFill>
-                <a:latin typeface="Arial"/>
-                <a:cs typeface="Arial"/>
-              </a:rPr>
-              <a:t> حل أمثل على IBM الكمّي</a:t>
+              <a:t>حل أمثل على IBM الكمّي</a:t>
             </a:r>
           </a:p>
         </p:txBody>
@@ -4253,7 +4266,7 @@
                 <a:latin typeface="Arial"/>
                 <a:cs typeface="Arial"/>
               </a:rPr>
-              <a:t>github.com/hasa32054-crypto/ACRS</a:t>
+              <a:t>MITRE (2024). Attack Flow corpus.</a:t>
             </a:r>
           </a:p>
         </p:txBody>
@@ -5344,7 +5357,7 @@
                 <a:latin typeface="Arial"/>
                 <a:cs typeface="Arial"/>
               </a:rPr>
-              <a:t>سياسة القرار (بلا حماية، عزل كامل، قاعدة بسيطة، ACRS).</a:t>
+              <a:t>سياسة القرار: الضابطة، العزل الكامل، القاعدة البسيطة، ACRS.</a:t>
             </a:r>
           </a:p>
           <a:p>
@@ -5398,7 +5411,7 @@
                 <a:latin typeface="Arial"/>
                 <a:cs typeface="Arial"/>
               </a:rPr>
-              <a:t>الأوزان، والعتبة 7.</a:t>
+              <a:t>الأوزان، والعتبة 7، والبذور.</a:t>
             </a:r>
           </a:p>
         </p:txBody>
@@ -5606,149 +5619,7 @@
               </a:defRPr>
             </a:defPPr>
           </a:lstStyle>
-          <a:p>
-            <a:pPr algn="r" rtl="1">
-              <a:spcAft>
-                <a:spcPts val="300"/>
-              </a:spcAft>
-              <a:defRPr sz="1500" b="0">
-                <a:solidFill>
-                  <a:srgbClr val="B0BAC0"/>
-                </a:solidFill>
-                <a:latin typeface="Arial"/>
-                <a:ea typeface="Arial"/>
-                <a:cs typeface="Arial"/>
-              </a:defRPr>
-            </a:pPr>
-            <a:r>
-              <a:rPr sz="1500" b="1" lang="ar-SA">
-                <a:solidFill>
-                  <a:srgbClr val="008A58"/>
-                </a:solidFill>
-                <a:latin typeface="Arial"/>
-                <a:cs typeface="Arial"/>
-              </a:rPr>
-              <a:t>١ </a:t>
-            </a:r>
-            <a:r>
-              <a:rPr sz="1500" b="0" lang="ar-SA">
-                <a:solidFill>
-                  <a:srgbClr val="1C2328"/>
-                </a:solidFill>
-                <a:latin typeface="Arial"/>
-                <a:cs typeface="Arial"/>
-              </a:rPr>
-              <a:t>تنبيه بالهجوم (تقنية ATT&amp;CK على جهاز)</a:t>
-            </a:r>
-          </a:p>
-          <a:p>
-            <a:pPr algn="r" rtl="1">
-              <a:spcAft>
-                <a:spcPts val="300"/>
-              </a:spcAft>
-            </a:pPr>
-            <a:r>
-              <a:rPr sz="1500" b="1" lang="ar-SA">
-                <a:solidFill>
-                  <a:srgbClr val="008A58"/>
-                </a:solidFill>
-                <a:latin typeface="Arial"/>
-                <a:cs typeface="Arial"/>
-              </a:rPr>
-              <a:t>٢ </a:t>
-            </a:r>
-            <a:r>
-              <a:rPr sz="1500" b="0" lang="ar-SA">
-                <a:solidFill>
-                  <a:srgbClr val="1C2328"/>
-                </a:solidFill>
-                <a:latin typeface="Arial"/>
-                <a:cs typeface="Arial"/>
-              </a:rPr>
-              <a:t>أرضية أمان: مشفَّر ← عزل، خادم حرج ← تجزئة تُبقي خدمته</a:t>
-            </a:r>
-          </a:p>
-          <a:p>
-            <a:pPr algn="r" rtl="1">
-              <a:spcAft>
-                <a:spcPts val="300"/>
-              </a:spcAft>
-            </a:pPr>
-            <a:r>
-              <a:rPr sz="1500" b="1" lang="ar-SA">
-                <a:solidFill>
-                  <a:srgbClr val="008A58"/>
-                </a:solidFill>
-                <a:latin typeface="Arial"/>
-                <a:cs typeface="Arial"/>
-              </a:rPr>
-              <a:t>٣ </a:t>
-            </a:r>
-            <a:r>
-              <a:rPr sz="1500" b="0" lang="ar-SA">
-                <a:solidFill>
-                  <a:srgbClr val="1C2328"/>
-                </a:solidFill>
-                <a:latin typeface="Arial"/>
-                <a:cs typeface="Arial"/>
-              </a:rPr>
-              <a:t>مُحسِّن QUBO يختار أقل إجراء لبقية الشبكة</a:t>
-            </a:r>
-          </a:p>
-          <a:p>
-            <a:pPr algn="r" rtl="1">
-              <a:spcAft>
-                <a:spcPts val="300"/>
-              </a:spcAft>
-            </a:pPr>
-            <a:r>
-              <a:rPr sz="1500" b="1" lang="ar-SA">
-                <a:solidFill>
-                  <a:srgbClr val="008A58"/>
-                </a:solidFill>
-                <a:latin typeface="Arial"/>
-                <a:cs typeface="Arial"/>
-              </a:rPr>
-              <a:t>٤ </a:t>
-            </a:r>
-            <a:r>
-              <a:rPr sz="1500" b="0" lang="ar-SA">
-                <a:solidFill>
-                  <a:srgbClr val="1C2328"/>
-                </a:solidFill>
-                <a:latin typeface="Arial"/>
-                <a:cs typeface="Arial"/>
-              </a:rPr>
-              <a:t>بوابة سلامة مستقلة: القرار الحرج لموافقة شخصين</a:t>
-            </a:r>
-          </a:p>
-          <a:p>
-            <a:pPr algn="r" rtl="1">
-              <a:spcAft>
-                <a:spcPts val="300"/>
-              </a:spcAft>
-            </a:pPr>
-            <a:r>
-              <a:rPr sz="1500" b="1" lang="ar-SA">
-                <a:solidFill>
-                  <a:srgbClr val="008A58"/>
-                </a:solidFill>
-                <a:latin typeface="Arial"/>
-                <a:cs typeface="Arial"/>
-              </a:rPr>
-              <a:t>٥ </a:t>
-            </a:r>
-            <a:r>
-              <a:rPr sz="1500" b="0" lang="ar-SA">
-                <a:solidFill>
-                  <a:srgbClr val="1C2328"/>
-                </a:solidFill>
-                <a:latin typeface="Arial"/>
-                <a:cs typeface="Arial"/>
-              </a:rPr>
-              <a:t>تنفيذ في جدار Linux حقيقي + شهادة موقّعة</a:t>
-            </a:r>
-          </a:p>
+          <a:p/>
         </p:txBody>
       </p:sp>
       <p:sp>
@@ -5969,24 +5840,41 @@
               </a:defRPr>
             </a:pPr>
             <a:r>
-              <a:rPr sz="1300" b="1" lang="ar-SA">
+              <a:rPr sz="1200" b="1" lang="ar-SA">
                 <a:solidFill>
                   <a:srgbClr val="1C2328"/>
                 </a:solidFill>
                 <a:latin typeface="Arial"/>
                 <a:cs typeface="Arial"/>
               </a:rPr>
-              <a:t>83</a:t>
-            </a:r>
-            <a:r>
-              <a:rPr sz="1300" b="0" lang="ar-SA">
+              <a:t>المجموعات التجريبية على نفس الهجمات:</a:t>
+            </a:r>
+          </a:p>
+          <a:p>
+            <a:pPr algn="r" rtl="1">
+              <a:spcAft>
+                <a:spcPts val="300"/>
+              </a:spcAft>
+            </a:pPr>
+            <a:r>
+              <a:rPr sz="1200" b="1" lang="ar-SA">
+                <a:solidFill>
+                  <a:srgbClr val="008A58"/>
+                </a:solidFill>
+                <a:latin typeface="Arial"/>
+                <a:cs typeface="Arial"/>
+              </a:rPr>
+              <a:t>الضابطة </a:t>
+            </a:r>
+            <a:r>
+              <a:rPr sz="1200" b="0" lang="ar-SA">
                 <a:solidFill>
                   <a:srgbClr val="1C2328"/>
                 </a:solidFill>
                 <a:latin typeface="Arial"/>
                 <a:cs typeface="Arial"/>
               </a:rPr>
-              <a:t> حادثة حقيقية 2013–2026، منها WannaCry وColonial وHSE</a:t>
+              <a:t>بلا حماية: 23 مسارًا مفتوحًا إلى خوادم حرجة</a:t>
             </a:r>
           </a:p>
           <a:p>
@@ -5996,71 +5884,105 @@
               </a:spcAft>
             </a:pPr>
             <a:r>
-              <a:rPr sz="1300" b="1" lang="ar-SA">
+              <a:rPr sz="1200" b="1" lang="ar-SA">
+                <a:solidFill>
+                  <a:srgbClr val="008A58"/>
+                </a:solidFill>
+                <a:latin typeface="Arial"/>
+                <a:cs typeface="Arial"/>
+              </a:rPr>
+              <a:t>أ </a:t>
+            </a:r>
+            <a:r>
+              <a:rPr sz="1200" b="0" lang="ar-SA">
                 <a:solidFill>
                   <a:srgbClr val="1C2328"/>
                 </a:solidFill>
                 <a:latin typeface="Arial"/>
                 <a:cs typeface="Arial"/>
               </a:rPr>
-              <a:t>4,000+</a:t>
-            </a:r>
-            <a:r>
-              <a:rPr sz="1300" b="0" lang="ar-SA">
+              <a:t>محاكاة: 4,000+ سيناريو تركيبي و894 واقعي</a:t>
+            </a:r>
+          </a:p>
+          <a:p>
+            <a:pPr algn="r" rtl="1">
+              <a:spcAft>
+                <a:spcPts val="300"/>
+              </a:spcAft>
+            </a:pPr>
+            <a:r>
+              <a:rPr sz="1200" b="1" lang="ar-SA">
+                <a:solidFill>
+                  <a:srgbClr val="008A58"/>
+                </a:solidFill>
+                <a:latin typeface="Arial"/>
+                <a:cs typeface="Arial"/>
+              </a:rPr>
+              <a:t>ب </a:t>
+            </a:r>
+            <a:r>
+              <a:rPr sz="1200" b="0" lang="ar-SA">
                 <a:solidFill>
                   <a:srgbClr val="1C2328"/>
                 </a:solidFill>
                 <a:latin typeface="Arial"/>
                 <a:cs typeface="Arial"/>
               </a:rPr>
-              <a:t> سيناريو تركيبي و</a:t>
-            </a:r>
-            <a:r>
-              <a:rPr sz="1300" b="1" lang="ar-SA">
+              <a:t>نواة Linux: نفس القواعد تُختبر حاسوبيًا ثم فعليًا (66/66)</a:t>
+            </a:r>
+          </a:p>
+          <a:p>
+            <a:pPr algn="r" rtl="1">
+              <a:spcAft>
+                <a:spcPts val="300"/>
+              </a:spcAft>
+            </a:pPr>
+            <a:r>
+              <a:rPr sz="1200" b="1" lang="ar-SA">
+                <a:solidFill>
+                  <a:srgbClr val="008A58"/>
+                </a:solidFill>
+                <a:latin typeface="Arial"/>
+                <a:cs typeface="Arial"/>
+              </a:rPr>
+              <a:t>ج </a:t>
+            </a:r>
+            <a:r>
+              <a:rPr sz="1200" b="0" lang="ar-SA">
                 <a:solidFill>
                   <a:srgbClr val="1C2328"/>
                 </a:solidFill>
                 <a:latin typeface="Arial"/>
                 <a:cs typeface="Arial"/>
               </a:rPr>
-              <a:t>894</a:t>
-            </a:r>
-            <a:r>
-              <a:rPr sz="1300" b="0" lang="ar-SA">
+              <a:t>كمّي: 3 حواسيب IBM، الأمثل 11/11</a:t>
+            </a:r>
+          </a:p>
+          <a:p>
+            <a:pPr algn="r" rtl="1">
+              <a:spcAft>
+                <a:spcPts val="300"/>
+              </a:spcAft>
+            </a:pPr>
+            <a:r>
+              <a:rPr sz="1200" b="1" lang="ar-SA">
+                <a:solidFill>
+                  <a:srgbClr val="008A58"/>
+                </a:solidFill>
+                <a:latin typeface="Arial"/>
+                <a:cs typeface="Arial"/>
+              </a:rPr>
+              <a:t>د </a:t>
+            </a:r>
+            <a:r>
+              <a:rPr sz="1200" b="0" lang="ar-SA">
                 <a:solidFill>
                   <a:srgbClr val="1C2328"/>
                 </a:solidFill>
                 <a:latin typeface="Arial"/>
                 <a:cs typeface="Arial"/>
               </a:rPr>
-              <a:t> واقعي، على شبكات صحية وصناعية ومصرفية وجامعية</a:t>
-            </a:r>
-          </a:p>
-          <a:p>
-            <a:pPr algn="r" rtl="1">
-              <a:spcAft>
-                <a:spcPts val="300"/>
-              </a:spcAft>
-            </a:pPr>
-            <a:r>
-              <a:rPr sz="1300" b="1" lang="ar-SA">
-                <a:solidFill>
-                  <a:srgbClr val="1C2328"/>
-                </a:solidFill>
-                <a:latin typeface="Arial"/>
-                <a:cs typeface="Arial"/>
-              </a:rPr>
-              <a:t>3</a:t>
-            </a:r>
-            <a:r>
-              <a:rPr sz="1300" b="0" lang="ar-SA">
-                <a:solidFill>
-                  <a:srgbClr val="1C2328"/>
-                </a:solidFill>
-                <a:latin typeface="Arial"/>
-                <a:cs typeface="Arial"/>
-              </a:rPr>
-              <a:t> حواسيب IBM كمّية، وجدار Linux حقيقي</a:t>
+              <a:t>الابتكار: 83 حادثة حقيقية 2013–2026</a:t>
             </a:r>
           </a:p>
         </p:txBody>
@@ -6489,14 +6411,24 @@
               </a:defRPr>
             </a:pPr>
             <a:r>
-              <a:rPr sz="1200" b="0" lang="ar-SA">
+              <a:rPr sz="1100" b="1" lang="ar-SA">
                 <a:solidFill>
                   <a:srgbClr val="1C2328"/>
                 </a:solidFill>
                 <a:latin typeface="Arial"/>
                 <a:cs typeface="Arial"/>
               </a:rPr>
-              <a:t>فترات ثقة Wilson، وMcNemar، وWilcoxon (α = 0.05)؛ والخدمات المتوقفة تُحسب بعد موافقة البشر.</a:t>
+              <a:t>نوتة الحمل: </a:t>
+            </a:r>
+            <a:r>
+              <a:rPr sz="1100" b="0" lang="ar-SA">
+                <a:solidFill>
+                  <a:srgbClr val="1C2328"/>
+                </a:solidFill>
+                <a:latin typeface="Arial"/>
+                <a:cs typeface="Arial"/>
+              </a:rPr>
+              <a:t>1,000 جهاز ← 2.3 مللي ثانية · 1,000 تنبيه دفعة ← 0.7 ثانية · Wilson وMcNemar وWilcoxon</a:t>
             </a:r>
           </a:p>
         </p:txBody>
@@ -6708,9 +6640,44 @@
           </a:p>
         </p:txBody>
       </p:sp>
+      <p:sp>
+        <p:nvSpPr>
+          <p:cNvPr id="63" name="TextBox 62"/>
+          <p:cNvSpPr txBox="1"/>
+          <p:nvPr/>
+        </p:nvSpPr>
+        <p:spPr>
+          <a:xfrm>
+            <a:off x="2300000" y="4960000"/>
+            <a:ext cx="7900000" cy="520000"/>
+          </a:xfrm>
+          <a:prstGeom prst="rect">
+            <a:avLst/>
+          </a:prstGeom>
+          <a:noFill/>
+        </p:spPr>
+        <p:txBody>
+          <a:bodyPr wrap="square" anchor="ctr">
+            <a:spAutoFit/>
+          </a:bodyPr>
+          <a:lstStyle/>
+          <a:p>
+            <a:pPr algn="ctr" rtl="1"/>
+            <a:r>
+              <a:rPr sz="1900">
+                <a:solidFill>
+                  <a:srgbClr val="FFFFFF"/>
+                </a:solidFill>
+                <a:latin typeface="Arial"/>
+              </a:rPr>
+              <a:t>يوقف المهاجم بأقل إجراء آمن… ويُبقي الخدمات تعمل</a:t>
+            </a:r>
+          </a:p>
+        </p:txBody>
+      </p:sp>
       <p:pic>
         <p:nvPicPr>
-          <p:cNvPr id="63" name="Picture 62" descr="chart.png"/>
+          <p:cNvPr id="64" name="Picture 63" descr="pipe.png"/>
           <p:cNvPicPr>
             <a:picLocks noChangeAspect="1"/>
           </p:cNvPicPr>
@@ -6724,6 +6691,30 @@
         </p:blipFill>
         <p:spPr>
           <a:xfrm>
+            <a:off x="3469475" y="6506006"/>
+            <a:ext cx="5529275" cy="1675537"/>
+          </a:xfrm>
+          <a:prstGeom prst="rect">
+            <a:avLst/>
+          </a:prstGeom>
+        </p:spPr>
+      </p:pic>
+      <p:pic>
+        <p:nvPicPr>
+          <p:cNvPr id="65" name="Picture 64" descr="chart.png"/>
+          <p:cNvPicPr>
+            <a:picLocks noChangeAspect="1"/>
+          </p:cNvPicPr>
+          <p:nvPr/>
+        </p:nvPicPr>
+        <p:blipFill>
+          <a:blip r:embed="rId6"/>
+          <a:stretch>
+            <a:fillRect/>
+          </a:stretch>
+        </p:blipFill>
+        <p:spPr>
+          <a:xfrm>
             <a:off x="3479475" y="10848583"/>
             <a:ext cx="5509275" cy="2248683"/>
           </a:xfrm>
@@ -6732,6 +6723,263 @@
           </a:prstGeom>
         </p:spPr>
       </p:pic>
+      <p:sp>
+        <p:nvSpPr>
+          <p:cNvPr id="66" name="Rounded Rectangle 65"/>
+          <p:cNvSpPr/>
+          <p:nvPr/>
+        </p:nvSpPr>
+        <p:spPr>
+          <a:xfrm>
+            <a:off x="8978700" y="14980000"/>
+            <a:ext cx="3180000" cy="1250000"/>
+          </a:xfrm>
+          <a:prstGeom prst="roundRect">
+            <a:avLst>
+              <a:gd name="adj" fmla="val 12000"/>
+            </a:avLst>
+          </a:prstGeom>
+          <a:solidFill>
+            <a:srgbClr val="417FB5"/>
+          </a:solidFill>
+          <a:ln>
+            <a:noFill/>
+          </a:ln>
+        </p:spPr>
+        <p:style>
+          <a:lnRef idx="1">
+            <a:schemeClr val="accent1"/>
+          </a:lnRef>
+          <a:fillRef idx="3">
+            <a:schemeClr val="accent1"/>
+          </a:fillRef>
+          <a:effectRef idx="2">
+            <a:schemeClr val="accent1"/>
+          </a:effectRef>
+          <a:fontRef idx="minor">
+            <a:schemeClr val="lt1"/>
+          </a:fontRef>
+        </p:style>
+        <p:txBody>
+          <a:bodyPr rtlCol="0" anchor="ctr" wrap="square"/>
+          <a:lstStyle/>
+          <a:p>
+            <a:pPr algn="ctr" rtl="0"/>
+            <a:r>
+              <a:rPr sz="3400" b="1">
+                <a:solidFill>
+                  <a:srgbClr val="FFFFFF"/>
+                </a:solidFill>
+                <a:latin typeface="Arial"/>
+              </a:rPr>
+              <a:t>91%</a:t>
+            </a:r>
+          </a:p>
+          <a:p>
+            <a:pPr algn="ctr" rtl="1"/>
+            <a:r>
+              <a:rPr sz="1300">
+                <a:solidFill>
+                  <a:srgbClr val="FFFFFF"/>
+                </a:solidFill>
+                <a:latin typeface="Arial"/>
+              </a:rPr>
+              <a:t>احتواء تلقائي على 75 هجمة حقيقية جديدة</a:t>
+            </a:r>
+          </a:p>
+        </p:txBody>
+      </p:sp>
+      <p:sp>
+        <p:nvSpPr>
+          <p:cNvPr id="67" name="Rounded Rectangle 66"/>
+          <p:cNvSpPr/>
+          <p:nvPr/>
+        </p:nvSpPr>
+        <p:spPr>
+          <a:xfrm>
+            <a:off x="5598700" y="14980000"/>
+            <a:ext cx="3180000" cy="1250000"/>
+          </a:xfrm>
+          <a:prstGeom prst="roundRect">
+            <a:avLst>
+              <a:gd name="adj" fmla="val 12000"/>
+            </a:avLst>
+          </a:prstGeom>
+          <a:solidFill>
+            <a:srgbClr val="0DA4A6"/>
+          </a:solidFill>
+          <a:ln>
+            <a:noFill/>
+          </a:ln>
+        </p:spPr>
+        <p:style>
+          <a:lnRef idx="1">
+            <a:schemeClr val="accent1"/>
+          </a:lnRef>
+          <a:fillRef idx="3">
+            <a:schemeClr val="accent1"/>
+          </a:fillRef>
+          <a:effectRef idx="2">
+            <a:schemeClr val="accent1"/>
+          </a:effectRef>
+          <a:fontRef idx="minor">
+            <a:schemeClr val="lt1"/>
+          </a:fontRef>
+        </p:style>
+        <p:txBody>
+          <a:bodyPr rtlCol="0" anchor="ctr" wrap="square"/>
+          <a:lstStyle/>
+          <a:p>
+            <a:pPr algn="ctr" rtl="0"/>
+            <a:r>
+              <a:rPr sz="3400" b="1">
+                <a:solidFill>
+                  <a:srgbClr val="FFFFFF"/>
+                </a:solidFill>
+                <a:latin typeface="Arial"/>
+              </a:rPr>
+              <a:t>70 / 268</a:t>
+            </a:r>
+          </a:p>
+          <a:p>
+            <a:pPr algn="ctr" rtl="1"/>
+            <a:r>
+              <a:rPr sz="1300">
+                <a:solidFill>
+                  <a:srgbClr val="FFFFFF"/>
+                </a:solidFill>
+                <a:latin typeface="Arial"/>
+              </a:rPr>
+              <a:t>خدمة متوقفة مقابل العزل الكامل</a:t>
+            </a:r>
+          </a:p>
+        </p:txBody>
+      </p:sp>
+      <p:sp>
+        <p:nvSpPr>
+          <p:cNvPr id="68" name="Rounded Rectangle 67"/>
+          <p:cNvSpPr/>
+          <p:nvPr/>
+        </p:nvSpPr>
+        <p:spPr>
+          <a:xfrm>
+            <a:off x="2218700" y="14980000"/>
+            <a:ext cx="3180000" cy="1250000"/>
+          </a:xfrm>
+          <a:prstGeom prst="roundRect">
+            <a:avLst>
+              <a:gd name="adj" fmla="val 12000"/>
+            </a:avLst>
+          </a:prstGeom>
+          <a:solidFill>
+            <a:srgbClr val="00A866"/>
+          </a:solidFill>
+          <a:ln>
+            <a:noFill/>
+          </a:ln>
+        </p:spPr>
+        <p:style>
+          <a:lnRef idx="1">
+            <a:schemeClr val="accent1"/>
+          </a:lnRef>
+          <a:fillRef idx="3">
+            <a:schemeClr val="accent1"/>
+          </a:fillRef>
+          <a:effectRef idx="2">
+            <a:schemeClr val="accent1"/>
+          </a:effectRef>
+          <a:fontRef idx="minor">
+            <a:schemeClr val="lt1"/>
+          </a:fontRef>
+        </p:style>
+        <p:txBody>
+          <a:bodyPr rtlCol="0" anchor="ctr" wrap="square"/>
+          <a:lstStyle/>
+          <a:p>
+            <a:pPr algn="ctr" rtl="0"/>
+            <a:r>
+              <a:rPr sz="3400" b="1">
+                <a:solidFill>
+                  <a:srgbClr val="FFFFFF"/>
+                </a:solidFill>
+                <a:latin typeface="Arial"/>
+              </a:rPr>
+              <a:t>0</a:t>
+            </a:r>
+          </a:p>
+          <a:p>
+            <a:pPr algn="ctr" rtl="1"/>
+            <a:r>
+              <a:rPr sz="1300">
+                <a:solidFill>
+                  <a:srgbClr val="FFFFFF"/>
+                </a:solidFill>
+                <a:latin typeface="Arial"/>
+              </a:rPr>
+              <a:t>قرارات غير آمنة في كل التجارب</a:t>
+            </a:r>
+          </a:p>
+        </p:txBody>
+      </p:sp>
+      <p:pic>
+        <p:nvPicPr>
+          <p:cNvPr id="69" name="Picture 68" descr="qr.png"/>
+          <p:cNvPicPr>
+            <a:picLocks noChangeAspect="1"/>
+          </p:cNvPicPr>
+          <p:nvPr/>
+        </p:nvPicPr>
+        <p:blipFill>
+          <a:blip r:embed="rId7"/>
+          <a:stretch>
+            <a:fillRect/>
+          </a:stretch>
+        </p:blipFill>
+        <p:spPr>
+          <a:xfrm>
+            <a:off x="440000" y="14980000"/>
+            <a:ext cx="1020000" cy="1020000"/>
+          </a:xfrm>
+          <a:prstGeom prst="rect">
+            <a:avLst/>
+          </a:prstGeom>
+        </p:spPr>
+      </p:pic>
+      <p:sp>
+        <p:nvSpPr>
+          <p:cNvPr id="70" name="TextBox 69"/>
+          <p:cNvSpPr txBox="1"/>
+          <p:nvPr/>
+        </p:nvSpPr>
+        <p:spPr>
+          <a:xfrm>
+            <a:off x="300000" y="16010000"/>
+            <a:ext cx="1300000" cy="230000"/>
+          </a:xfrm>
+          <a:prstGeom prst="rect">
+            <a:avLst/>
+          </a:prstGeom>
+          <a:noFill/>
+        </p:spPr>
+        <p:txBody>
+          <a:bodyPr wrap="none">
+            <a:spAutoFit/>
+          </a:bodyPr>
+          <a:lstStyle/>
+          <a:p>
+            <a:pPr algn="ctr" rtl="1"/>
+            <a:r>
+              <a:rPr sz="1100" b="1">
+                <a:solidFill>
+                  <a:srgbClr val="1C2328"/>
+                </a:solidFill>
+                <a:latin typeface="Arial"/>
+              </a:rPr>
+              <a:t>الكود والنتائج</a:t>
+            </a:r>
+          </a:p>
+        </p:txBody>
+      </p:sp>
     </p:spTree>
     <p:extLst>
       <p:ext uri="{BB962C8B-B14F-4D97-AF65-F5344CB8AC3E}">

</xml_diff>

<commit_message>
Board v3: remove KPI tile band and QR (info already in the board boxes)
Co-Authored-By: Claude Opus 5.5 <noreply@anthropic.com>
Claude-Session: https://claude.ai/code/session_013B4LPWZWgdrx1XoL9LPLxx
</commit_message>
<xml_diff>
--- a/docs/qacrs/board/ACRS_board.pptx
+++ b/docs/qacrs/board/ACRS_board.pptx
@@ -6723,263 +6723,6 @@
           </a:prstGeom>
         </p:spPr>
       </p:pic>
-      <p:sp>
-        <p:nvSpPr>
-          <p:cNvPr id="66" name="Rounded Rectangle 65"/>
-          <p:cNvSpPr/>
-          <p:nvPr/>
-        </p:nvSpPr>
-        <p:spPr>
-          <a:xfrm>
-            <a:off x="8978700" y="14980000"/>
-            <a:ext cx="3180000" cy="1250000"/>
-          </a:xfrm>
-          <a:prstGeom prst="roundRect">
-            <a:avLst>
-              <a:gd name="adj" fmla="val 12000"/>
-            </a:avLst>
-          </a:prstGeom>
-          <a:solidFill>
-            <a:srgbClr val="417FB5"/>
-          </a:solidFill>
-          <a:ln>
-            <a:noFill/>
-          </a:ln>
-        </p:spPr>
-        <p:style>
-          <a:lnRef idx="1">
-            <a:schemeClr val="accent1"/>
-          </a:lnRef>
-          <a:fillRef idx="3">
-            <a:schemeClr val="accent1"/>
-          </a:fillRef>
-          <a:effectRef idx="2">
-            <a:schemeClr val="accent1"/>
-          </a:effectRef>
-          <a:fontRef idx="minor">
-            <a:schemeClr val="lt1"/>
-          </a:fontRef>
-        </p:style>
-        <p:txBody>
-          <a:bodyPr rtlCol="0" anchor="ctr" wrap="square"/>
-          <a:lstStyle/>
-          <a:p>
-            <a:pPr algn="ctr" rtl="0"/>
-            <a:r>
-              <a:rPr sz="3400" b="1">
-                <a:solidFill>
-                  <a:srgbClr val="FFFFFF"/>
-                </a:solidFill>
-                <a:latin typeface="Arial"/>
-              </a:rPr>
-              <a:t>91%</a:t>
-            </a:r>
-          </a:p>
-          <a:p>
-            <a:pPr algn="ctr" rtl="1"/>
-            <a:r>
-              <a:rPr sz="1300">
-                <a:solidFill>
-                  <a:srgbClr val="FFFFFF"/>
-                </a:solidFill>
-                <a:latin typeface="Arial"/>
-              </a:rPr>
-              <a:t>احتواء تلقائي على 75 هجمة حقيقية جديدة</a:t>
-            </a:r>
-          </a:p>
-        </p:txBody>
-      </p:sp>
-      <p:sp>
-        <p:nvSpPr>
-          <p:cNvPr id="67" name="Rounded Rectangle 66"/>
-          <p:cNvSpPr/>
-          <p:nvPr/>
-        </p:nvSpPr>
-        <p:spPr>
-          <a:xfrm>
-            <a:off x="5598700" y="14980000"/>
-            <a:ext cx="3180000" cy="1250000"/>
-          </a:xfrm>
-          <a:prstGeom prst="roundRect">
-            <a:avLst>
-              <a:gd name="adj" fmla="val 12000"/>
-            </a:avLst>
-          </a:prstGeom>
-          <a:solidFill>
-            <a:srgbClr val="0DA4A6"/>
-          </a:solidFill>
-          <a:ln>
-            <a:noFill/>
-          </a:ln>
-        </p:spPr>
-        <p:style>
-          <a:lnRef idx="1">
-            <a:schemeClr val="accent1"/>
-          </a:lnRef>
-          <a:fillRef idx="3">
-            <a:schemeClr val="accent1"/>
-          </a:fillRef>
-          <a:effectRef idx="2">
-            <a:schemeClr val="accent1"/>
-          </a:effectRef>
-          <a:fontRef idx="minor">
-            <a:schemeClr val="lt1"/>
-          </a:fontRef>
-        </p:style>
-        <p:txBody>
-          <a:bodyPr rtlCol="0" anchor="ctr" wrap="square"/>
-          <a:lstStyle/>
-          <a:p>
-            <a:pPr algn="ctr" rtl="0"/>
-            <a:r>
-              <a:rPr sz="3400" b="1">
-                <a:solidFill>
-                  <a:srgbClr val="FFFFFF"/>
-                </a:solidFill>
-                <a:latin typeface="Arial"/>
-              </a:rPr>
-              <a:t>70 / 268</a:t>
-            </a:r>
-          </a:p>
-          <a:p>
-            <a:pPr algn="ctr" rtl="1"/>
-            <a:r>
-              <a:rPr sz="1300">
-                <a:solidFill>
-                  <a:srgbClr val="FFFFFF"/>
-                </a:solidFill>
-                <a:latin typeface="Arial"/>
-              </a:rPr>
-              <a:t>خدمة متوقفة مقابل العزل الكامل</a:t>
-            </a:r>
-          </a:p>
-        </p:txBody>
-      </p:sp>
-      <p:sp>
-        <p:nvSpPr>
-          <p:cNvPr id="68" name="Rounded Rectangle 67"/>
-          <p:cNvSpPr/>
-          <p:nvPr/>
-        </p:nvSpPr>
-        <p:spPr>
-          <a:xfrm>
-            <a:off x="2218700" y="14980000"/>
-            <a:ext cx="3180000" cy="1250000"/>
-          </a:xfrm>
-          <a:prstGeom prst="roundRect">
-            <a:avLst>
-              <a:gd name="adj" fmla="val 12000"/>
-            </a:avLst>
-          </a:prstGeom>
-          <a:solidFill>
-            <a:srgbClr val="00A866"/>
-          </a:solidFill>
-          <a:ln>
-            <a:noFill/>
-          </a:ln>
-        </p:spPr>
-        <p:style>
-          <a:lnRef idx="1">
-            <a:schemeClr val="accent1"/>
-          </a:lnRef>
-          <a:fillRef idx="3">
-            <a:schemeClr val="accent1"/>
-          </a:fillRef>
-          <a:effectRef idx="2">
-            <a:schemeClr val="accent1"/>
-          </a:effectRef>
-          <a:fontRef idx="minor">
-            <a:schemeClr val="lt1"/>
-          </a:fontRef>
-        </p:style>
-        <p:txBody>
-          <a:bodyPr rtlCol="0" anchor="ctr" wrap="square"/>
-          <a:lstStyle/>
-          <a:p>
-            <a:pPr algn="ctr" rtl="0"/>
-            <a:r>
-              <a:rPr sz="3400" b="1">
-                <a:solidFill>
-                  <a:srgbClr val="FFFFFF"/>
-                </a:solidFill>
-                <a:latin typeface="Arial"/>
-              </a:rPr>
-              <a:t>0</a:t>
-            </a:r>
-          </a:p>
-          <a:p>
-            <a:pPr algn="ctr" rtl="1"/>
-            <a:r>
-              <a:rPr sz="1300">
-                <a:solidFill>
-                  <a:srgbClr val="FFFFFF"/>
-                </a:solidFill>
-                <a:latin typeface="Arial"/>
-              </a:rPr>
-              <a:t>قرارات غير آمنة في كل التجارب</a:t>
-            </a:r>
-          </a:p>
-        </p:txBody>
-      </p:sp>
-      <p:pic>
-        <p:nvPicPr>
-          <p:cNvPr id="69" name="Picture 68" descr="qr.png"/>
-          <p:cNvPicPr>
-            <a:picLocks noChangeAspect="1"/>
-          </p:cNvPicPr>
-          <p:nvPr/>
-        </p:nvPicPr>
-        <p:blipFill>
-          <a:blip r:embed="rId7"/>
-          <a:stretch>
-            <a:fillRect/>
-          </a:stretch>
-        </p:blipFill>
-        <p:spPr>
-          <a:xfrm>
-            <a:off x="440000" y="14980000"/>
-            <a:ext cx="1020000" cy="1020000"/>
-          </a:xfrm>
-          <a:prstGeom prst="rect">
-            <a:avLst/>
-          </a:prstGeom>
-        </p:spPr>
-      </p:pic>
-      <p:sp>
-        <p:nvSpPr>
-          <p:cNvPr id="70" name="TextBox 69"/>
-          <p:cNvSpPr txBox="1"/>
-          <p:nvPr/>
-        </p:nvSpPr>
-        <p:spPr>
-          <a:xfrm>
-            <a:off x="300000" y="16010000"/>
-            <a:ext cx="1300000" cy="230000"/>
-          </a:xfrm>
-          <a:prstGeom prst="rect">
-            <a:avLst/>
-          </a:prstGeom>
-          <a:noFill/>
-        </p:spPr>
-        <p:txBody>
-          <a:bodyPr wrap="none">
-            <a:spAutoFit/>
-          </a:bodyPr>
-          <a:lstStyle/>
-          <a:p>
-            <a:pPr algn="ctr" rtl="1"/>
-            <a:r>
-              <a:rPr sz="1100" b="1">
-                <a:solidFill>
-                  <a:srgbClr val="1C2328"/>
-                </a:solidFill>
-                <a:latin typeface="Arial"/>
-              </a:rPr>
-              <a:t>الكود والنتائج</a:t>
-            </a:r>
-          </a:p>
-        </p:txBody>
-      </p:sp>
     </p:spTree>
     <p:extLst>
       <p:ext uri="{BB962C8B-B14F-4D97-AF65-F5344CB8AC3E}">

</xml_diff>

<commit_message>
Board v4: screen-readable pipeline and chart, body stretched to fill the space
Co-Authored-By: Claude Opus 5.5 <noreply@anthropic.com>
Claude-Session: https://claude.ai/code/session_013B4LPWZWgdrx1XoL9LPLxx
</commit_message>
<xml_diff>
--- a/docs/qacrs/board/ACRS_board.pptx
+++ b/docs/qacrs/board/ACRS_board.pptx
@@ -2914,7 +2914,7 @@
         <p:spPr>
           <a:xfrm>
             <a:off x="238125" y="5629275"/>
-            <a:ext cx="2962275" cy="9153525"/>
+            <a:ext cx="2962275" cy="10550725"/>
           </a:xfrm>
           <a:custGeom>
             <a:avLst/>
@@ -3001,7 +3001,7 @@
         <p:spPr>
           <a:xfrm flipH="1">
             <a:off x="9277350" y="5629275"/>
-            <a:ext cx="2962275" cy="9153525"/>
+            <a:ext cx="2962275" cy="10550725"/>
           </a:xfrm>
           <a:custGeom>
             <a:avLst/>
@@ -3087,8 +3087,8 @@
         </p:nvSpPr>
         <p:spPr>
           <a:xfrm>
-            <a:off x="3314700" y="5924550"/>
-            <a:ext cx="5876925" cy="8362950"/>
+            <a:off x="3314700" y="5969620"/>
+            <a:ext cx="5876925" cy="9639476"/>
           </a:xfrm>
           <a:prstGeom prst="rect">
             <a:avLst/>
@@ -3141,8 +3141,8 @@
         </p:nvSpPr>
         <p:spPr>
           <a:xfrm>
-            <a:off x="276225" y="6010275"/>
-            <a:ext cx="2886075" cy="314325"/>
+            <a:off x="276225" y="6068431"/>
+            <a:ext cx="2886075" cy="362303"/>
           </a:xfrm>
           <a:prstGeom prst="rect">
             <a:avLst/>
@@ -3193,8 +3193,8 @@
         </p:nvSpPr>
         <p:spPr>
           <a:xfrm>
-            <a:off x="304800" y="6019800"/>
-            <a:ext cx="2828925" cy="295275"/>
+            <a:off x="304800" y="6079409"/>
+            <a:ext cx="2828925" cy="340345"/>
           </a:xfrm>
           <a:prstGeom prst="rect">
             <a:avLst/>
@@ -3262,8 +3262,8 @@
         </p:nvSpPr>
         <p:spPr>
           <a:xfrm>
-            <a:off x="409575" y="6477000"/>
-            <a:ext cx="2619375" cy="1295400"/>
+            <a:off x="409575" y="6606397"/>
+            <a:ext cx="2619375" cy="1493130"/>
           </a:xfrm>
           <a:prstGeom prst="rect">
             <a:avLst/>
@@ -3305,7 +3305,7 @@
               </a:defRPr>
             </a:pPr>
             <a:r>
-              <a:rPr sz="1500" b="1" lang="ar-SA">
+              <a:rPr sz="2000" b="1" lang="ar-SA">
                 <a:solidFill>
                   <a:srgbClr val="008A58"/>
                 </a:solidFill>
@@ -3315,7 +3315,7 @@
               <a:t>91%  </a:t>
             </a:r>
             <a:r>
-              <a:rPr sz="1200" b="0" lang="ar-SA">
+              <a:rPr sz="1400" b="0" lang="ar-SA">
                 <a:solidFill>
                   <a:srgbClr val="1C2328"/>
                 </a:solidFill>
@@ -3332,7 +3332,7 @@
               </a:spcAft>
             </a:pPr>
             <a:r>
-              <a:rPr sz="1500" b="1" lang="ar-SA">
+              <a:rPr sz="2000" b="1" lang="ar-SA">
                 <a:solidFill>
                   <a:srgbClr val="008A58"/>
                 </a:solidFill>
@@ -3342,7 +3342,7 @@
               <a:t>70  </a:t>
             </a:r>
             <a:r>
-              <a:rPr sz="1200" b="0" lang="ar-SA">
+              <a:rPr sz="1400" b="0" lang="ar-SA">
                 <a:solidFill>
                   <a:srgbClr val="1C2328"/>
                 </a:solidFill>
@@ -3359,7 +3359,7 @@
               </a:spcAft>
             </a:pPr>
             <a:r>
-              <a:rPr sz="1500" b="1" lang="ar-SA">
+              <a:rPr sz="2000" b="1" lang="ar-SA">
                 <a:solidFill>
                   <a:srgbClr val="008A58"/>
                 </a:solidFill>
@@ -3369,7 +3369,7 @@
               <a:t>0  </a:t>
             </a:r>
             <a:r>
-              <a:rPr sz="1200" b="0" lang="ar-SA">
+              <a:rPr sz="1400" b="0" lang="ar-SA">
                 <a:solidFill>
                   <a:srgbClr val="1C2328"/>
                 </a:solidFill>
@@ -3386,7 +3386,7 @@
               </a:spcAft>
             </a:pPr>
             <a:r>
-              <a:rPr sz="1500" b="1" lang="ar-SA">
+              <a:rPr sz="2000" b="1" lang="ar-SA">
                 <a:solidFill>
                   <a:srgbClr val="008A58"/>
                 </a:solidFill>
@@ -3396,14 +3396,14 @@
               <a:t>11/11  </a:t>
             </a:r>
             <a:r>
-              <a:rPr sz="1200" b="0" lang="ar-SA">
+              <a:rPr sz="1400" b="0" lang="ar-SA">
                 <a:solidFill>
                   <a:srgbClr val="1C2328"/>
                 </a:solidFill>
                 <a:latin typeface="Arial"/>
                 <a:cs typeface="Arial"/>
               </a:rPr>
-              <a:t>حل أمثل على IBM الكمّي</a:t>
+              <a:t>حل كمّي أمثل (IBM)</a:t>
             </a:r>
           </a:p>
         </p:txBody>
@@ -3424,8 +3424,8 @@
         </p:nvSpPr>
         <p:spPr>
           <a:xfrm>
-            <a:off x="276225" y="7924800"/>
-            <a:ext cx="2886075" cy="314325"/>
+            <a:off x="276225" y="8275190"/>
+            <a:ext cx="2886075" cy="362303"/>
           </a:xfrm>
           <a:prstGeom prst="rect">
             <a:avLst/>
@@ -3476,8 +3476,8 @@
         </p:nvSpPr>
         <p:spPr>
           <a:xfrm>
-            <a:off x="304800" y="7934325"/>
-            <a:ext cx="2828925" cy="295275"/>
+            <a:off x="304800" y="8286169"/>
+            <a:ext cx="2828925" cy="340345"/>
           </a:xfrm>
           <a:prstGeom prst="rect">
             <a:avLst/>
@@ -3545,8 +3545,8 @@
         </p:nvSpPr>
         <p:spPr>
           <a:xfrm>
-            <a:off x="409575" y="8391525"/>
-            <a:ext cx="2619375" cy="876300"/>
+            <a:off x="409575" y="8813156"/>
+            <a:ext cx="2619375" cy="1010059"/>
           </a:xfrm>
           <a:prstGeom prst="rect">
             <a:avLst/>
@@ -3588,7 +3588,7 @@
               </a:defRPr>
             </a:pPr>
             <a:r>
-              <a:rPr sz="1200" b="0" lang="ar-SA">
+              <a:rPr sz="1400" b="0" lang="ar-SA">
                 <a:solidFill>
                   <a:srgbClr val="1C2328"/>
                 </a:solidFill>
@@ -3605,7 +3605,7 @@
               </a:spcAft>
             </a:pPr>
             <a:r>
-              <a:rPr sz="1200" b="1" lang="ar-SA">
+              <a:rPr sz="1400" b="1" lang="ar-SA">
                 <a:solidFill>
                   <a:srgbClr val="1C2328"/>
                 </a:solidFill>
@@ -3615,7 +3615,7 @@
               <a:t>في HSE: </a:t>
             </a:r>
             <a:r>
-              <a:rPr sz="1200" b="0" lang="ar-SA">
+              <a:rPr sz="1400" b="0" lang="ar-SA">
                 <a:solidFill>
                   <a:srgbClr val="1C2328"/>
                 </a:solidFill>
@@ -3643,8 +3643,8 @@
         </p:nvSpPr>
         <p:spPr>
           <a:xfrm>
-            <a:off x="276225" y="9420225"/>
-            <a:ext cx="2886075" cy="314325"/>
+            <a:off x="276225" y="9998878"/>
+            <a:ext cx="2886075" cy="362303"/>
           </a:xfrm>
           <a:prstGeom prst="rect">
             <a:avLst/>
@@ -3695,8 +3695,8 @@
         </p:nvSpPr>
         <p:spPr>
           <a:xfrm>
-            <a:off x="304800" y="9429750"/>
-            <a:ext cx="2828925" cy="295275"/>
+            <a:off x="304800" y="10009856"/>
+            <a:ext cx="2828925" cy="340345"/>
           </a:xfrm>
           <a:prstGeom prst="rect">
             <a:avLst/>
@@ -3764,8 +3764,8 @@
         </p:nvSpPr>
         <p:spPr>
           <a:xfrm>
-            <a:off x="409575" y="9886950"/>
-            <a:ext cx="2619375" cy="876300"/>
+            <a:off x="409575" y="10536844"/>
+            <a:ext cx="2619375" cy="1010059"/>
           </a:xfrm>
           <a:prstGeom prst="rect">
             <a:avLst/>
@@ -3807,7 +3807,7 @@
               </a:defRPr>
             </a:pPr>
             <a:r>
-              <a:rPr sz="1200" b="0" lang="ar-SA">
+              <a:rPr sz="1400" b="0" lang="ar-SA">
                 <a:solidFill>
                   <a:srgbClr val="1C2328"/>
                 </a:solidFill>
@@ -3824,7 +3824,7 @@
               </a:spcAft>
             </a:pPr>
             <a:r>
-              <a:rPr sz="1200" b="0" lang="ar-SA">
+              <a:rPr sz="1400" b="0" lang="ar-SA">
                 <a:solidFill>
                   <a:srgbClr val="1C2328"/>
                 </a:solidFill>
@@ -3852,8 +3852,8 @@
         </p:nvSpPr>
         <p:spPr>
           <a:xfrm>
-            <a:off x="276225" y="10915650"/>
-            <a:ext cx="2886075" cy="314325"/>
+            <a:off x="276225" y="11722565"/>
+            <a:ext cx="2886075" cy="362303"/>
           </a:xfrm>
           <a:prstGeom prst="rect">
             <a:avLst/>
@@ -3904,8 +3904,8 @@
         </p:nvSpPr>
         <p:spPr>
           <a:xfrm>
-            <a:off x="304800" y="10925175"/>
-            <a:ext cx="2828925" cy="295275"/>
+            <a:off x="304800" y="11733544"/>
+            <a:ext cx="2828925" cy="340345"/>
           </a:xfrm>
           <a:prstGeom prst="rect">
             <a:avLst/>
@@ -3973,8 +3973,8 @@
         </p:nvSpPr>
         <p:spPr>
           <a:xfrm>
-            <a:off x="409575" y="11382375"/>
-            <a:ext cx="2619375" cy="904875"/>
+            <a:off x="409575" y="12260531"/>
+            <a:ext cx="2619375" cy="1042995"/>
           </a:xfrm>
           <a:prstGeom prst="rect">
             <a:avLst/>
@@ -4016,7 +4016,7 @@
               </a:defRPr>
             </a:pPr>
             <a:r>
-              <a:rPr sz="1200" b="0" lang="ar-SA">
+              <a:rPr sz="1400" b="0" lang="ar-SA">
                 <a:solidFill>
                   <a:srgbClr val="1C2328"/>
                 </a:solidFill>
@@ -4044,8 +4044,8 @@
         </p:nvSpPr>
         <p:spPr>
           <a:xfrm>
-            <a:off x="276225" y="12439650"/>
-            <a:ext cx="2886075" cy="314325"/>
+            <a:off x="276225" y="13479190"/>
+            <a:ext cx="2886075" cy="362303"/>
           </a:xfrm>
           <a:prstGeom prst="rect">
             <a:avLst/>
@@ -4096,8 +4096,8 @@
         </p:nvSpPr>
         <p:spPr>
           <a:xfrm>
-            <a:off x="304800" y="12449175"/>
-            <a:ext cx="2828925" cy="295275"/>
+            <a:off x="304800" y="13490168"/>
+            <a:ext cx="2828925" cy="340345"/>
           </a:xfrm>
           <a:prstGeom prst="rect">
             <a:avLst/>
@@ -4165,8 +4165,8 @@
         </p:nvSpPr>
         <p:spPr>
           <a:xfrm>
-            <a:off x="409575" y="12906375"/>
-            <a:ext cx="2619375" cy="1133475"/>
+            <a:off x="409575" y="14017156"/>
+            <a:ext cx="2619375" cy="1306489"/>
           </a:xfrm>
           <a:prstGeom prst="rect">
             <a:avLst/>
@@ -4208,7 +4208,7 @@
               </a:defRPr>
             </a:pPr>
             <a:r>
-              <a:rPr sz="1100" b="0" lang="ar-SA">
+              <a:rPr sz="1300" b="0" lang="ar-SA">
                 <a:solidFill>
                   <a:srgbClr val="1C2328"/>
                 </a:solidFill>
@@ -4225,7 +4225,7 @@
               </a:spcAft>
             </a:pPr>
             <a:r>
-              <a:rPr sz="1100" b="0" lang="ar-SA">
+              <a:rPr sz="1300" b="0" lang="ar-SA">
                 <a:solidFill>
                   <a:srgbClr val="1C2328"/>
                 </a:solidFill>
@@ -4242,7 +4242,7 @@
               </a:spcAft>
             </a:pPr>
             <a:r>
-              <a:rPr sz="1100" b="0" lang="ar-SA">
+              <a:rPr sz="1300" b="0" lang="ar-SA">
                 <a:solidFill>
                   <a:srgbClr val="1C2328"/>
                 </a:solidFill>
@@ -4259,7 +4259,7 @@
               </a:spcAft>
             </a:pPr>
             <a:r>
-              <a:rPr sz="1100" b="0" lang="ar-SA">
+              <a:rPr sz="1300" b="0" lang="ar-SA">
                 <a:solidFill>
                   <a:srgbClr val="1C2328"/>
                 </a:solidFill>
@@ -4287,8 +4287,8 @@
         </p:nvSpPr>
         <p:spPr>
           <a:xfrm>
-            <a:off x="9315450" y="6010275"/>
-            <a:ext cx="2886075" cy="314325"/>
+            <a:off x="9315450" y="6068431"/>
+            <a:ext cx="2886075" cy="362303"/>
           </a:xfrm>
           <a:prstGeom prst="rect">
             <a:avLst/>
@@ -4339,8 +4339,8 @@
         </p:nvSpPr>
         <p:spPr>
           <a:xfrm>
-            <a:off x="9344025" y="6019800"/>
-            <a:ext cx="2828925" cy="295275"/>
+            <a:off x="9344025" y="6079409"/>
+            <a:ext cx="2828925" cy="340345"/>
           </a:xfrm>
           <a:prstGeom prst="rect">
             <a:avLst/>
@@ -4408,8 +4408,8 @@
         </p:nvSpPr>
         <p:spPr>
           <a:xfrm>
-            <a:off x="9448800" y="6477000"/>
-            <a:ext cx="2619375" cy="1123950"/>
+            <a:off x="9448800" y="6606397"/>
+            <a:ext cx="2619375" cy="1295510"/>
           </a:xfrm>
           <a:prstGeom prst="rect">
             <a:avLst/>
@@ -4451,7 +4451,7 @@
               </a:defRPr>
             </a:pPr>
             <a:r>
-              <a:rPr sz="1300" b="0" lang="ar-SA">
+              <a:rPr sz="1500" b="0" lang="ar-SA">
                 <a:solidFill>
                   <a:srgbClr val="1C2328"/>
                 </a:solidFill>
@@ -4468,7 +4468,7 @@
               </a:spcAft>
             </a:pPr>
             <a:r>
-              <a:rPr sz="1300" b="0" lang="ar-SA">
+              <a:rPr sz="1500" b="0" lang="ar-SA">
                 <a:solidFill>
                   <a:srgbClr val="1C2328"/>
                 </a:solidFill>
@@ -4478,7 +4478,7 @@
               <a:t>في WannaCry تعطلت </a:t>
             </a:r>
             <a:r>
-              <a:rPr sz="1300" b="1" lang="ar-SA">
+              <a:rPr sz="1500" b="1" lang="ar-SA">
                 <a:solidFill>
                   <a:srgbClr val="1C2328"/>
                 </a:solidFill>
@@ -4488,7 +4488,7 @@
               <a:t>46 جهة صحية</a:t>
             </a:r>
             <a:r>
-              <a:rPr sz="1300" b="0" lang="ar-SA">
+              <a:rPr sz="1500" b="0" lang="ar-SA">
                 <a:solidFill>
                   <a:srgbClr val="1C2328"/>
                 </a:solidFill>
@@ -4516,8 +4516,8 @@
         </p:nvSpPr>
         <p:spPr>
           <a:xfrm>
-            <a:off x="9315450" y="7753350"/>
-            <a:ext cx="2886075" cy="314325"/>
+            <a:off x="9315450" y="8077570"/>
+            <a:ext cx="2886075" cy="362303"/>
           </a:xfrm>
           <a:prstGeom prst="rect">
             <a:avLst/>
@@ -4568,8 +4568,8 @@
         </p:nvSpPr>
         <p:spPr>
           <a:xfrm>
-            <a:off x="9344025" y="7762875"/>
-            <a:ext cx="2828925" cy="295275"/>
+            <a:off x="9344025" y="8088549"/>
+            <a:ext cx="2828925" cy="340345"/>
           </a:xfrm>
           <a:prstGeom prst="rect">
             <a:avLst/>
@@ -4637,8 +4637,8 @@
         </p:nvSpPr>
         <p:spPr>
           <a:xfrm>
-            <a:off x="9448800" y="8220075"/>
-            <a:ext cx="2619375" cy="1143000"/>
+            <a:off x="9448800" y="8615536"/>
+            <a:ext cx="2619375" cy="1317468"/>
           </a:xfrm>
           <a:prstGeom prst="rect">
             <a:avLst/>
@@ -4680,7 +4680,7 @@
               </a:defRPr>
             </a:pPr>
             <a:r>
-              <a:rPr sz="1300" b="0" lang="ar-SA">
+              <a:rPr sz="1500" b="0" lang="ar-SA">
                 <a:solidFill>
                   <a:srgbClr val="1C2328"/>
                 </a:solidFill>
@@ -4697,7 +4697,7 @@
               </a:spcAft>
             </a:pPr>
             <a:r>
-              <a:rPr sz="1300" b="1" lang="ar-SA">
+              <a:rPr sz="1500" b="1" lang="ar-SA">
                 <a:solidFill>
                   <a:srgbClr val="1C2328"/>
                 </a:solidFill>
@@ -4707,7 +4707,7 @@
               <a:t>دون كسر أي قاعدة سلامة</a:t>
             </a:r>
             <a:r>
-              <a:rPr sz="1300" b="0" lang="ar-SA">
+              <a:rPr sz="1500" b="0" lang="ar-SA">
                 <a:solidFill>
                   <a:srgbClr val="1C2328"/>
                 </a:solidFill>
@@ -4735,8 +4735,8 @@
         </p:nvSpPr>
         <p:spPr>
           <a:xfrm>
-            <a:off x="9315450" y="9515475"/>
-            <a:ext cx="2886075" cy="314325"/>
+            <a:off x="9315450" y="10108667"/>
+            <a:ext cx="2886075" cy="362303"/>
           </a:xfrm>
           <a:prstGeom prst="rect">
             <a:avLst/>
@@ -4787,8 +4787,8 @@
         </p:nvSpPr>
         <p:spPr>
           <a:xfrm>
-            <a:off x="9344025" y="9525000"/>
-            <a:ext cx="2828925" cy="295275"/>
+            <a:off x="9344025" y="10119645"/>
+            <a:ext cx="2828925" cy="340345"/>
           </a:xfrm>
           <a:prstGeom prst="rect">
             <a:avLst/>
@@ -4856,8 +4856,8 @@
         </p:nvSpPr>
         <p:spPr>
           <a:xfrm>
-            <a:off x="9448800" y="9982200"/>
-            <a:ext cx="2619375" cy="647700"/>
+            <a:off x="9448800" y="10646633"/>
+            <a:ext cx="2619375" cy="746565"/>
           </a:xfrm>
           <a:prstGeom prst="rect">
             <a:avLst/>
@@ -4899,7 +4899,7 @@
               </a:defRPr>
             </a:pPr>
             <a:r>
-              <a:rPr sz="1200" b="0" lang="ar-SA">
+              <a:rPr sz="1300" b="0" lang="ar-SA">
                 <a:solidFill>
                   <a:srgbClr val="1C2328"/>
                 </a:solidFill>
@@ -4927,8 +4927,8 @@
         </p:nvSpPr>
         <p:spPr>
           <a:xfrm>
-            <a:off x="9315450" y="10782300"/>
-            <a:ext cx="2886075" cy="314325"/>
+            <a:off x="9315450" y="11568861"/>
+            <a:ext cx="2886075" cy="362303"/>
           </a:xfrm>
           <a:prstGeom prst="rect">
             <a:avLst/>
@@ -4979,8 +4979,8 @@
         </p:nvSpPr>
         <p:spPr>
           <a:xfrm>
-            <a:off x="9344025" y="10791825"/>
-            <a:ext cx="2828925" cy="295275"/>
+            <a:off x="9344025" y="11579839"/>
+            <a:ext cx="2828925" cy="340345"/>
           </a:xfrm>
           <a:prstGeom prst="rect">
             <a:avLst/>
@@ -5048,8 +5048,8 @@
         </p:nvSpPr>
         <p:spPr>
           <a:xfrm>
-            <a:off x="9448800" y="11249025"/>
-            <a:ext cx="2619375" cy="1143000"/>
+            <a:off x="9448800" y="12106827"/>
+            <a:ext cx="2619375" cy="1317468"/>
           </a:xfrm>
           <a:prstGeom prst="rect">
             <a:avLst/>
@@ -5091,7 +5091,7 @@
               </a:defRPr>
             </a:pPr>
             <a:r>
-              <a:rPr sz="1300" b="0" lang="ar-SA">
+              <a:rPr sz="1500" b="0" lang="ar-SA">
                 <a:solidFill>
                   <a:srgbClr val="1C2328"/>
                 </a:solidFill>
@@ -5101,7 +5101,7 @@
               <a:t>ACRS يحتوي </a:t>
             </a:r>
             <a:r>
-              <a:rPr sz="1300" b="1" lang="ar-SA">
+              <a:rPr sz="1500" b="1" lang="ar-SA">
                 <a:solidFill>
                   <a:srgbClr val="1C2328"/>
                 </a:solidFill>
@@ -5111,7 +5111,7 @@
               <a:t>≥ 80%</a:t>
             </a:r>
             <a:r>
-              <a:rPr sz="1300" b="0" lang="ar-SA">
+              <a:rPr sz="1500" b="0" lang="ar-SA">
                 <a:solidFill>
                   <a:srgbClr val="1C2328"/>
                 </a:solidFill>
@@ -5121,7 +5121,7 @@
               <a:t> مما يحتويه العزل الكامل، بخدمات متوقفة أقل، و</a:t>
             </a:r>
             <a:r>
-              <a:rPr sz="1300" b="1" lang="ar-SA">
+              <a:rPr sz="1500" b="1" lang="ar-SA">
                 <a:solidFill>
                   <a:srgbClr val="1C2328"/>
                 </a:solidFill>
@@ -5131,7 +5131,7 @@
               <a:t>0</a:t>
             </a:r>
             <a:r>
-              <a:rPr sz="1300" b="0" lang="ar-SA">
+              <a:rPr sz="1500" b="0" lang="ar-SA">
                 <a:solidFill>
                   <a:srgbClr val="1C2328"/>
                 </a:solidFill>
@@ -5148,7 +5148,7 @@
               </a:spcAft>
             </a:pPr>
             <a:r>
-              <a:rPr sz="1300" b="0" lang="ar-SA">
+              <a:rPr sz="1500" b="0" lang="ar-SA">
                 <a:solidFill>
                   <a:srgbClr val="1C2328"/>
                 </a:solidFill>
@@ -5176,8 +5176,8 @@
         </p:nvSpPr>
         <p:spPr>
           <a:xfrm>
-            <a:off x="9315450" y="12544425"/>
-            <a:ext cx="2886075" cy="314325"/>
+            <a:off x="9315450" y="13599957"/>
+            <a:ext cx="2886075" cy="362303"/>
           </a:xfrm>
           <a:prstGeom prst="rect">
             <a:avLst/>
@@ -5228,8 +5228,8 @@
         </p:nvSpPr>
         <p:spPr>
           <a:xfrm>
-            <a:off x="9344025" y="12553950"/>
-            <a:ext cx="2828925" cy="295275"/>
+            <a:off x="9344025" y="13610936"/>
+            <a:ext cx="2828925" cy="340345"/>
           </a:xfrm>
           <a:prstGeom prst="rect">
             <a:avLst/>
@@ -5297,8 +5297,8 @@
         </p:nvSpPr>
         <p:spPr>
           <a:xfrm>
-            <a:off x="9448800" y="13011150"/>
-            <a:ext cx="2619375" cy="1028700"/>
+            <a:off x="9448800" y="14137924"/>
+            <a:ext cx="2619375" cy="1185721"/>
           </a:xfrm>
           <a:prstGeom prst="rect">
             <a:avLst/>
@@ -5340,7 +5340,7 @@
               </a:defRPr>
             </a:pPr>
             <a:r>
-              <a:rPr sz="1200" b="1" lang="ar-SA">
+              <a:rPr sz="1400" b="1" lang="ar-SA">
                 <a:solidFill>
                   <a:srgbClr val="1C2328"/>
                 </a:solidFill>
@@ -5350,7 +5350,7 @@
               <a:t>المستقل: </a:t>
             </a:r>
             <a:r>
-              <a:rPr sz="1200" b="0" lang="ar-SA">
+              <a:rPr sz="1400" b="0" lang="ar-SA">
                 <a:solidFill>
                   <a:srgbClr val="1C2328"/>
                 </a:solidFill>
@@ -5367,7 +5367,7 @@
               </a:spcAft>
             </a:pPr>
             <a:r>
-              <a:rPr sz="1200" b="1" lang="ar-SA">
+              <a:rPr sz="1400" b="1" lang="ar-SA">
                 <a:solidFill>
                   <a:srgbClr val="1C2328"/>
                 </a:solidFill>
@@ -5377,7 +5377,7 @@
               <a:t>التابع: </a:t>
             </a:r>
             <a:r>
-              <a:rPr sz="1200" b="0" lang="ar-SA">
+              <a:rPr sz="1400" b="0" lang="ar-SA">
                 <a:solidFill>
                   <a:srgbClr val="1C2328"/>
                 </a:solidFill>
@@ -5394,7 +5394,7 @@
               </a:spcAft>
             </a:pPr>
             <a:r>
-              <a:rPr sz="1200" b="1" lang="ar-SA">
+              <a:rPr sz="1400" b="1" lang="ar-SA">
                 <a:solidFill>
                   <a:srgbClr val="1C2328"/>
                 </a:solidFill>
@@ -5404,7 +5404,7 @@
               <a:t>الضابط: </a:t>
             </a:r>
             <a:r>
-              <a:rPr sz="1200" b="0" lang="ar-SA">
+              <a:rPr sz="1400" b="0" lang="ar-SA">
                 <a:solidFill>
                   <a:srgbClr val="1C2328"/>
                 </a:solidFill>
@@ -5432,8 +5432,8 @@
         </p:nvSpPr>
         <p:spPr>
           <a:xfrm>
-            <a:off x="5138738" y="6048375"/>
-            <a:ext cx="2190750" cy="314325"/>
+            <a:off x="5138738" y="6112346"/>
+            <a:ext cx="2190750" cy="362303"/>
           </a:xfrm>
           <a:prstGeom prst="rect">
             <a:avLst/>
@@ -5484,8 +5484,8 @@
         </p:nvSpPr>
         <p:spPr>
           <a:xfrm>
-            <a:off x="5167313" y="6057900"/>
-            <a:ext cx="2133600" cy="295275"/>
+            <a:off x="5167313" y="6123325"/>
+            <a:ext cx="2133600" cy="340345"/>
           </a:xfrm>
           <a:prstGeom prst="rect">
             <a:avLst/>
@@ -5553,8 +5553,8 @@
         </p:nvSpPr>
         <p:spPr>
           <a:xfrm>
-            <a:off x="3419475" y="6419850"/>
-            <a:ext cx="5629275" cy="1847850"/>
+            <a:off x="3419475" y="6540523"/>
+            <a:ext cx="5629275" cy="2129907"/>
           </a:xfrm>
           <a:prstGeom prst="rect">
             <a:avLst/>
@@ -5591,8 +5591,8 @@
         </p:nvSpPr>
         <p:spPr>
           <a:xfrm>
-            <a:off x="3552825" y="6515100"/>
-            <a:ext cx="5362575" cy="1657350"/>
+            <a:off x="3552825" y="6650312"/>
+            <a:ext cx="5362575" cy="1910328"/>
           </a:xfrm>
           <a:prstGeom prst="rect">
             <a:avLst/>
@@ -5638,8 +5638,8 @@
         </p:nvSpPr>
         <p:spPr>
           <a:xfrm>
-            <a:off x="5138738" y="8391525"/>
-            <a:ext cx="2190750" cy="314325"/>
+            <a:off x="5138738" y="8813156"/>
+            <a:ext cx="2190750" cy="362303"/>
           </a:xfrm>
           <a:prstGeom prst="rect">
             <a:avLst/>
@@ -5690,8 +5690,8 @@
         </p:nvSpPr>
         <p:spPr>
           <a:xfrm>
-            <a:off x="5167313" y="8401050"/>
-            <a:ext cx="2133600" cy="295275"/>
+            <a:off x="5167313" y="8824135"/>
+            <a:ext cx="2133600" cy="340345"/>
           </a:xfrm>
           <a:prstGeom prst="rect">
             <a:avLst/>
@@ -5759,8 +5759,8 @@
         </p:nvSpPr>
         <p:spPr>
           <a:xfrm>
-            <a:off x="3419475" y="8763000"/>
-            <a:ext cx="5629275" cy="1571625"/>
+            <a:off x="3419475" y="9241333"/>
+            <a:ext cx="5629275" cy="1811518"/>
           </a:xfrm>
           <a:prstGeom prst="rect">
             <a:avLst/>
@@ -5797,8 +5797,8 @@
         </p:nvSpPr>
         <p:spPr>
           <a:xfrm>
-            <a:off x="3552825" y="8858250"/>
-            <a:ext cx="5362575" cy="1381125"/>
+            <a:off x="3552825" y="9351122"/>
+            <a:ext cx="5362575" cy="1591940"/>
           </a:xfrm>
           <a:prstGeom prst="rect">
             <a:avLst/>
@@ -5840,7 +5840,7 @@
               </a:defRPr>
             </a:pPr>
             <a:r>
-              <a:rPr sz="1200" b="1" lang="ar-SA">
+              <a:rPr sz="1400" b="1" lang="ar-SA">
                 <a:solidFill>
                   <a:srgbClr val="1C2328"/>
                 </a:solidFill>
@@ -5857,7 +5857,7 @@
               </a:spcAft>
             </a:pPr>
             <a:r>
-              <a:rPr sz="1200" b="1" lang="ar-SA">
+              <a:rPr sz="1400" b="1" lang="ar-SA">
                 <a:solidFill>
                   <a:srgbClr val="008A58"/>
                 </a:solidFill>
@@ -5867,7 +5867,7 @@
               <a:t>الضابطة </a:t>
             </a:r>
             <a:r>
-              <a:rPr sz="1200" b="0" lang="ar-SA">
+              <a:rPr sz="1400" b="0" lang="ar-SA">
                 <a:solidFill>
                   <a:srgbClr val="1C2328"/>
                 </a:solidFill>
@@ -5884,7 +5884,7 @@
               </a:spcAft>
             </a:pPr>
             <a:r>
-              <a:rPr sz="1200" b="1" lang="ar-SA">
+              <a:rPr sz="1400" b="1" lang="ar-SA">
                 <a:solidFill>
                   <a:srgbClr val="008A58"/>
                 </a:solidFill>
@@ -5894,7 +5894,7 @@
               <a:t>أ </a:t>
             </a:r>
             <a:r>
-              <a:rPr sz="1200" b="0" lang="ar-SA">
+              <a:rPr sz="1400" b="0" lang="ar-SA">
                 <a:solidFill>
                   <a:srgbClr val="1C2328"/>
                 </a:solidFill>
@@ -5911,7 +5911,7 @@
               </a:spcAft>
             </a:pPr>
             <a:r>
-              <a:rPr sz="1200" b="1" lang="ar-SA">
+              <a:rPr sz="1400" b="1" lang="ar-SA">
                 <a:solidFill>
                   <a:srgbClr val="008A58"/>
                 </a:solidFill>
@@ -5921,7 +5921,7 @@
               <a:t>ب </a:t>
             </a:r>
             <a:r>
-              <a:rPr sz="1200" b="0" lang="ar-SA">
+              <a:rPr sz="1400" b="0" lang="ar-SA">
                 <a:solidFill>
                   <a:srgbClr val="1C2328"/>
                 </a:solidFill>
@@ -5938,7 +5938,7 @@
               </a:spcAft>
             </a:pPr>
             <a:r>
-              <a:rPr sz="1200" b="1" lang="ar-SA">
+              <a:rPr sz="1400" b="1" lang="ar-SA">
                 <a:solidFill>
                   <a:srgbClr val="008A58"/>
                 </a:solidFill>
@@ -5948,7 +5948,7 @@
               <a:t>ج </a:t>
             </a:r>
             <a:r>
-              <a:rPr sz="1200" b="0" lang="ar-SA">
+              <a:rPr sz="1400" b="0" lang="ar-SA">
                 <a:solidFill>
                   <a:srgbClr val="1C2328"/>
                 </a:solidFill>
@@ -5965,7 +5965,7 @@
               </a:spcAft>
             </a:pPr>
             <a:r>
-              <a:rPr sz="1200" b="1" lang="ar-SA">
+              <a:rPr sz="1400" b="1" lang="ar-SA">
                 <a:solidFill>
                   <a:srgbClr val="008A58"/>
                 </a:solidFill>
@@ -5975,7 +5975,7 @@
               <a:t>د </a:t>
             </a:r>
             <a:r>
-              <a:rPr sz="1200" b="0" lang="ar-SA">
+              <a:rPr sz="1400" b="0" lang="ar-SA">
                 <a:solidFill>
                   <a:srgbClr val="1C2328"/>
                 </a:solidFill>
@@ -6003,8 +6003,8 @@
         </p:nvSpPr>
         <p:spPr>
           <a:xfrm>
-            <a:off x="5138738" y="10448925"/>
-            <a:ext cx="2190750" cy="314325"/>
+            <a:off x="5138738" y="11184599"/>
+            <a:ext cx="2190750" cy="362303"/>
           </a:xfrm>
           <a:prstGeom prst="rect">
             <a:avLst/>
@@ -6055,8 +6055,8 @@
         </p:nvSpPr>
         <p:spPr>
           <a:xfrm>
-            <a:off x="5167313" y="10458450"/>
-            <a:ext cx="2133600" cy="295275"/>
+            <a:off x="5167313" y="11195578"/>
+            <a:ext cx="2133600" cy="340345"/>
           </a:xfrm>
           <a:prstGeom prst="rect">
             <a:avLst/>
@@ -6124,8 +6124,8 @@
         </p:nvSpPr>
         <p:spPr>
           <a:xfrm>
-            <a:off x="3419475" y="10820400"/>
-            <a:ext cx="5629275" cy="2305050"/>
+            <a:off x="3419475" y="11612776"/>
+            <a:ext cx="5629275" cy="2656894"/>
           </a:xfrm>
           <a:prstGeom prst="rect">
             <a:avLst/>
@@ -6162,8 +6162,8 @@
         </p:nvSpPr>
         <p:spPr>
           <a:xfrm>
-            <a:off x="3552825" y="10915650"/>
-            <a:ext cx="5362575" cy="2114550"/>
+            <a:off x="3552825" y="11722565"/>
+            <a:ext cx="5362575" cy="2437316"/>
           </a:xfrm>
           <a:prstGeom prst="rect">
             <a:avLst/>
@@ -6209,8 +6209,8 @@
         </p:nvSpPr>
         <p:spPr>
           <a:xfrm>
-            <a:off x="5138738" y="13249275"/>
-            <a:ext cx="2190750" cy="314325"/>
+            <a:off x="5138738" y="14412396"/>
+            <a:ext cx="2190750" cy="362303"/>
           </a:xfrm>
           <a:prstGeom prst="rect">
             <a:avLst/>
@@ -6261,8 +6261,8 @@
         </p:nvSpPr>
         <p:spPr>
           <a:xfrm>
-            <a:off x="5167313" y="13258800"/>
-            <a:ext cx="2133600" cy="295275"/>
+            <a:off x="5167313" y="14423375"/>
+            <a:ext cx="2133600" cy="340345"/>
           </a:xfrm>
           <a:prstGeom prst="rect">
             <a:avLst/>
@@ -6330,8 +6330,8 @@
         </p:nvSpPr>
         <p:spPr>
           <a:xfrm>
-            <a:off x="3419475" y="13620750"/>
-            <a:ext cx="5629275" cy="590550"/>
+            <a:off x="3419475" y="14840573"/>
+            <a:ext cx="5629275" cy="680691"/>
           </a:xfrm>
           <a:prstGeom prst="rect">
             <a:avLst/>
@@ -6368,8 +6368,8 @@
         </p:nvSpPr>
         <p:spPr>
           <a:xfrm>
-            <a:off x="3552825" y="13716000"/>
-            <a:ext cx="5362575" cy="400050"/>
+            <a:off x="3552825" y="14950362"/>
+            <a:ext cx="5362575" cy="461113"/>
           </a:xfrm>
           <a:prstGeom prst="rect">
             <a:avLst/>
@@ -6691,8 +6691,8 @@
         </p:blipFill>
         <p:spPr>
           <a:xfrm>
-            <a:off x="3469475" y="6506006"/>
-            <a:ext cx="5529275" cy="1675537"/>
+            <a:off x="3469475" y="6573345"/>
+            <a:ext cx="5529275" cy="2064262"/>
           </a:xfrm>
           <a:prstGeom prst="rect">
             <a:avLst/>
@@ -6715,8 +6715,8 @@
         </p:blipFill>
         <p:spPr>
           <a:xfrm>
-            <a:off x="3479475" y="10848583"/>
-            <a:ext cx="5509275" cy="2248683"/>
+            <a:off x="3479475" y="11620121"/>
+            <a:ext cx="5509275" cy="2642203"/>
           </a:xfrm>
           <a:prstGeom prst="rect">
             <a:avLst/>

</xml_diff>

<commit_message>
Board v5: plain-language wording for non-technical visitors (numbers unchanged)
Co-Authored-By: Claude Opus 5.5 <noreply@anthropic.com>
Claude-Session: https://claude.ai/code/session_013B4LPWZWgdrx1XoL9LPLxx
</commit_message>
<xml_diff>
--- a/docs/qacrs/board/ACRS_board.pptx
+++ b/docs/qacrs/board/ACRS_board.pptx
@@ -3315,14 +3315,14 @@
               <a:t>91%  </a:t>
             </a:r>
             <a:r>
-              <a:rPr sz="1400" b="0" lang="ar-SA">
+              <a:rPr sz="1300" b="0" lang="ar-SA">
                 <a:solidFill>
                   <a:srgbClr val="1C2328"/>
                 </a:solidFill>
                 <a:latin typeface="Arial"/>
                 <a:cs typeface="Arial"/>
               </a:rPr>
-              <a:t>احتواء تلقائي</a:t>
+              <a:t>من الهجمات احتواها تلقائيًا</a:t>
             </a:r>
           </a:p>
           <a:p>
@@ -3342,14 +3342,14 @@
               <a:t>70  </a:t>
             </a:r>
             <a:r>
-              <a:rPr sz="1400" b="0" lang="ar-SA">
+              <a:rPr sz="1300" b="0" lang="ar-SA">
                 <a:solidFill>
                   <a:srgbClr val="1C2328"/>
                 </a:solidFill>
                 <a:latin typeface="Arial"/>
                 <a:cs typeface="Arial"/>
               </a:rPr>
-              <a:t>خدمة متوقفة مقابل 268</a:t>
+              <a:t>خدمة تعطّلت بدل 268</a:t>
             </a:r>
           </a:p>
           <a:p>
@@ -3369,14 +3369,14 @@
               <a:t>0  </a:t>
             </a:r>
             <a:r>
-              <a:rPr sz="1400" b="0" lang="ar-SA">
+              <a:rPr sz="1300" b="0" lang="ar-SA">
                 <a:solidFill>
                   <a:srgbClr val="1C2328"/>
                 </a:solidFill>
                 <a:latin typeface="Arial"/>
                 <a:cs typeface="Arial"/>
               </a:rPr>
-              <a:t>قرارات غير آمنة</a:t>
+              <a:t>قرارات خطيرة</a:t>
             </a:r>
           </a:p>
           <a:p>
@@ -3396,14 +3396,14 @@
               <a:t>11/11  </a:t>
             </a:r>
             <a:r>
-              <a:rPr sz="1400" b="0" lang="ar-SA">
+              <a:rPr sz="1300" b="0" lang="ar-SA">
                 <a:solidFill>
                   <a:srgbClr val="1C2328"/>
                 </a:solidFill>
                 <a:latin typeface="Arial"/>
                 <a:cs typeface="Arial"/>
               </a:rPr>
-              <a:t>حل كمّي أمثل (IBM)</a:t>
+              <a:t>أفضل حل كمّي</a:t>
             </a:r>
           </a:p>
         </p:txBody>
@@ -3588,14 +3588,14 @@
               </a:defRPr>
             </a:pPr>
             <a:r>
-              <a:rPr sz="1400" b="0" lang="ar-SA">
+              <a:rPr sz="1300" b="0" lang="ar-SA">
                 <a:solidFill>
                   <a:srgbClr val="1C2328"/>
                 </a:solidFill>
                 <a:latin typeface="Arial"/>
                 <a:cs typeface="Arial"/>
               </a:rPr>
-              <a:t>يمكن احتواء الهجوم دون إيقاف الخدمات متى وصل التنبيه.</a:t>
+              <a:t>نقدر نوقف المخترق بدون ما نطفي الخدمات، من أول تنبيه.</a:t>
             </a:r>
           </a:p>
           <a:p>
@@ -3605,24 +3605,24 @@
               </a:spcAft>
             </a:pPr>
             <a:r>
-              <a:rPr sz="1400" b="1" lang="ar-SA">
+              <a:rPr sz="1300" b="1" lang="ar-SA">
                 <a:solidFill>
                   <a:srgbClr val="1C2328"/>
                 </a:solidFill>
                 <a:latin typeface="Arial"/>
                 <a:cs typeface="Arial"/>
               </a:rPr>
-              <a:t>في HSE: </a:t>
-            </a:r>
-            <a:r>
-              <a:rPr sz="1400" b="0" lang="ar-SA">
+              <a:t>مثال HSE (مستشفيات إيرلندا): </a:t>
+            </a:r>
+            <a:r>
+              <a:rPr sz="1300" b="0" lang="ar-SA">
                 <a:solidFill>
                   <a:srgbClr val="1C2328"/>
                 </a:solidFill>
                 <a:latin typeface="Arial"/>
                 <a:cs typeface="Arial"/>
               </a:rPr>
-              <a:t>جهاز واحد عند أول تنبيه بدل 9 خدمات بعد 6 أسابيع.</a:t>
+              <a:t>فصل جهاز واحد كان يكفي، بدل تعطّل 9 خدمات بعد 6 أسابيع.</a:t>
             </a:r>
           </a:p>
         </p:txBody>
@@ -3807,14 +3807,14 @@
               </a:defRPr>
             </a:pPr>
             <a:r>
-              <a:rPr sz="1400" b="0" lang="ar-SA">
+              <a:rPr sz="1300" b="0" lang="ar-SA">
                 <a:solidFill>
                   <a:srgbClr val="1C2328"/>
                 </a:solidFill>
                 <a:latin typeface="Arial"/>
                 <a:cs typeface="Arial"/>
               </a:rPr>
-              <a:t>المستشفيات، والبنوك، والجامعات، والبنى الحيوية.</a:t>
+              <a:t>المستشفيات، والبنوك، والجامعات، والمرافق المهمة مثل الكهرباء والماء.</a:t>
             </a:r>
           </a:p>
           <a:p>
@@ -3824,14 +3824,14 @@
               </a:spcAft>
             </a:pPr>
             <a:r>
-              <a:rPr sz="1400" b="0" lang="ar-SA">
+              <a:rPr sz="1300" b="0" lang="ar-SA">
                 <a:solidFill>
                   <a:srgbClr val="1C2328"/>
                 </a:solidFill>
                 <a:latin typeface="Arial"/>
                 <a:cs typeface="Arial"/>
               </a:rPr>
-              <a:t>مصمَّم لدعم الضوابط الأساسية للأمن السيبراني ECC-2:2024.</a:t>
+              <a:t>مصمَّم لدعم ضوابط الأمن السيبراني الوطنية ECC-2:2024.</a:t>
             </a:r>
           </a:p>
         </p:txBody>
@@ -4016,14 +4016,14 @@
               </a:defRPr>
             </a:pPr>
             <a:r>
-              <a:rPr sz="1400" b="0" lang="ar-SA">
+              <a:rPr sz="1300" b="0" lang="ar-SA">
                 <a:solidFill>
                   <a:srgbClr val="1C2328"/>
                 </a:solidFill>
                 <a:latin typeface="Arial"/>
                 <a:cs typeface="Arial"/>
               </a:rPr>
-              <a:t>جهاز ACRS Box (Raspberry Pi 5)، ومقاومة المهاجم الذكي، والتنفيذ على حاسوب أرامكو/Pasqal الكمّي، ونشر ورقة علمية.</a:t>
+              <a:t>جهاز ACRS Box صغير يُركّب بالشبكة، ومواجهة المخترق الذكي، وتجربة الحاسوب الكمّي في أرامكو، ونشر بحث علمي.</a:t>
             </a:r>
           </a:p>
         </p:txBody>
@@ -4451,14 +4451,14 @@
               </a:defRPr>
             </a:pPr>
             <a:r>
-              <a:rPr sz="1500" b="0" lang="ar-SA">
+              <a:rPr sz="1400" b="0" lang="ar-SA">
                 <a:solidFill>
                   <a:srgbClr val="1C2328"/>
                 </a:solidFill>
                 <a:latin typeface="Arial"/>
                 <a:cs typeface="Arial"/>
               </a:rPr>
-              <a:t>العزل الكامل عند الهجوم يوقف خدمات سليمة.</a:t>
+              <a:t>لما يُخترق جهاز، الحل المعتاد قطع الشبكة كلها… فتتعطّل خدمات سليمة.</a:t>
             </a:r>
           </a:p>
           <a:p>
@@ -4468,17 +4468,17 @@
               </a:spcAft>
             </a:pPr>
             <a:r>
-              <a:rPr sz="1500" b="0" lang="ar-SA">
+              <a:rPr sz="1400" b="0" lang="ar-SA">
                 <a:solidFill>
                   <a:srgbClr val="1C2328"/>
                 </a:solidFill>
                 <a:latin typeface="Arial"/>
                 <a:cs typeface="Arial"/>
               </a:rPr>
-              <a:t>في WannaCry تعطلت </a:t>
-            </a:r>
-            <a:r>
-              <a:rPr sz="1500" b="1" lang="ar-SA">
+              <a:t>في هجوم WannaCry تعطّلت </a:t>
+            </a:r>
+            <a:r>
+              <a:rPr sz="1400" b="1" lang="ar-SA">
                 <a:solidFill>
                   <a:srgbClr val="1C2328"/>
                 </a:solidFill>
@@ -4488,14 +4488,14 @@
               <a:t>46 جهة صحية</a:t>
             </a:r>
             <a:r>
-              <a:rPr sz="1500" b="0" lang="ar-SA">
+              <a:rPr sz="1400" b="0" lang="ar-SA">
                 <a:solidFill>
                   <a:srgbClr val="1C2328"/>
                 </a:solidFill>
                 <a:latin typeface="Arial"/>
                 <a:cs typeface="Arial"/>
               </a:rPr>
-              <a:t> لم تُصب أصلًا.</a:t>
+              <a:t> ما وصلها الهجوم أصلًا.</a:t>
             </a:r>
           </a:p>
         </p:txBody>
@@ -4680,14 +4680,14 @@
               </a:defRPr>
             </a:pPr>
             <a:r>
-              <a:rPr sz="1500" b="0" lang="ar-SA">
+              <a:rPr sz="1400" b="0" lang="ar-SA">
                 <a:solidFill>
                   <a:srgbClr val="1C2328"/>
                 </a:solidFill>
                 <a:latin typeface="Arial"/>
                 <a:cs typeface="Arial"/>
               </a:rPr>
-              <a:t>اختيار أقل إجراء يوقف المهاجم ويُبقي الخدمات تعمل،</a:t>
+              <a:t>نوقف المخترق بأصغر خطوة ممكنة، ونخلي باقي الخدمات شغّالة،</a:t>
             </a:r>
           </a:p>
           <a:p>
@@ -4697,24 +4697,24 @@
               </a:spcAft>
             </a:pPr>
             <a:r>
-              <a:rPr sz="1500" b="1" lang="ar-SA">
+              <a:rPr sz="1400" b="1" lang="ar-SA">
                 <a:solidFill>
                   <a:srgbClr val="1C2328"/>
                 </a:solidFill>
                 <a:latin typeface="Arial"/>
                 <a:cs typeface="Arial"/>
               </a:rPr>
-              <a:t>دون كسر أي قاعدة سلامة</a:t>
-            </a:r>
-            <a:r>
-              <a:rPr sz="1500" b="0" lang="ar-SA">
+              <a:t>بدون كسر أي قاعدة أمان</a:t>
+            </a:r>
+            <a:r>
+              <a:rPr sz="1400" b="0" lang="ar-SA">
                 <a:solidFill>
                   <a:srgbClr val="1C2328"/>
                 </a:solidFill>
                 <a:latin typeface="Arial"/>
                 <a:cs typeface="Arial"/>
               </a:rPr>
-              <a:t> وبقرار قابل للتحقق.</a:t>
+              <a:t>، وكل قرار يقدر أحد يراجعه.</a:t>
             </a:r>
           </a:p>
         </p:txBody>
@@ -4906,7 +4906,7 @@
                 <a:latin typeface="Arial"/>
                 <a:cs typeface="Arial"/>
               </a:rPr>
-              <a:t>تحسين ثنائي QUBO يُحل كلاسيكيًا وعلى حاسوب IBM الكمّي (QAOA)، مع MITRE ATT&amp;CK وCVSS.</a:t>
+              <a:t>النظام يحل القرار مثل لغز: يوازن الخيارات ويختار الأفضل، على كمبيوتر عادي وعلى حاسوب كمّي من IBM.</a:t>
             </a:r>
           </a:p>
         </p:txBody>
@@ -5091,37 +5091,37 @@
               </a:defRPr>
             </a:pPr>
             <a:r>
-              <a:rPr sz="1500" b="0" lang="ar-SA">
+              <a:rPr sz="1300" b="0" lang="ar-SA">
                 <a:solidFill>
                   <a:srgbClr val="1C2328"/>
                 </a:solidFill>
                 <a:latin typeface="Arial"/>
                 <a:cs typeface="Arial"/>
               </a:rPr>
-              <a:t>ACRS يحتوي </a:t>
-            </a:r>
-            <a:r>
-              <a:rPr sz="1500" b="1" lang="ar-SA">
+              <a:t>نتوقع أن ACRS يوقف المخترق في </a:t>
+            </a:r>
+            <a:r>
+              <a:rPr sz="1300" b="1" lang="ar-SA">
                 <a:solidFill>
                   <a:srgbClr val="1C2328"/>
                 </a:solidFill>
                 <a:latin typeface="Arial"/>
                 <a:cs typeface="Arial"/>
               </a:rPr>
-              <a:t>≥ 80%</a:t>
-            </a:r>
-            <a:r>
-              <a:rPr sz="1500" b="0" lang="ar-SA">
+              <a:t>80%</a:t>
+            </a:r>
+            <a:r>
+              <a:rPr sz="1300" b="0" lang="ar-SA">
                 <a:solidFill>
                   <a:srgbClr val="1C2328"/>
                 </a:solidFill>
                 <a:latin typeface="Arial"/>
                 <a:cs typeface="Arial"/>
               </a:rPr>
-              <a:t> مما يحتويه العزل الكامل، بخدمات متوقفة أقل، و</a:t>
-            </a:r>
-            <a:r>
-              <a:rPr sz="1500" b="1" lang="ar-SA">
+              <a:t> أو أكثر مما يوقفه قطع الشبكة كلها، لكن يعطّل خدمات أقل، و</a:t>
+            </a:r>
+            <a:r>
+              <a:rPr sz="1300" b="1" lang="ar-SA">
                 <a:solidFill>
                   <a:srgbClr val="1C2328"/>
                 </a:solidFill>
@@ -5131,14 +5131,14 @@
               <a:t>0</a:t>
             </a:r>
             <a:r>
-              <a:rPr sz="1500" b="0" lang="ar-SA">
+              <a:rPr sz="1300" b="0" lang="ar-SA">
                 <a:solidFill>
                   <a:srgbClr val="1C2328"/>
                 </a:solidFill>
                 <a:latin typeface="Arial"/>
                 <a:cs typeface="Arial"/>
               </a:rPr>
-              <a:t> قرارات غير آمنة.</a:t>
+              <a:t> قرارات خطيرة.</a:t>
             </a:r>
           </a:p>
           <a:p>
@@ -5148,14 +5148,14 @@
               </a:spcAft>
             </a:pPr>
             <a:r>
-              <a:rPr sz="1500" b="0" lang="ar-SA">
+              <a:rPr sz="1300" b="0" lang="ar-SA">
                 <a:solidFill>
                   <a:srgbClr val="1C2328"/>
                 </a:solidFill>
                 <a:latin typeface="Arial"/>
                 <a:cs typeface="Arial"/>
               </a:rPr>
-              <a:t>كل فرضية مسجّلة في Git قبل التجربة.</a:t>
+              <a:t>كتبنا التوقع وحفظناه قبل التجربة.</a:t>
             </a:r>
           </a:p>
         </p:txBody>
@@ -5340,24 +5340,24 @@
               </a:defRPr>
             </a:pPr>
             <a:r>
-              <a:rPr sz="1400" b="1" lang="ar-SA">
+              <a:rPr sz="1300" b="1" lang="ar-SA">
                 <a:solidFill>
                   <a:srgbClr val="1C2328"/>
                 </a:solidFill>
                 <a:latin typeface="Arial"/>
                 <a:cs typeface="Arial"/>
               </a:rPr>
-              <a:t>المستقل: </a:t>
-            </a:r>
-            <a:r>
-              <a:rPr sz="1400" b="0" lang="ar-SA">
+              <a:t>اللي نغيّره: </a:t>
+            </a:r>
+            <a:r>
+              <a:rPr sz="1300" b="0" lang="ar-SA">
                 <a:solidFill>
                   <a:srgbClr val="1C2328"/>
                 </a:solidFill>
                 <a:latin typeface="Arial"/>
                 <a:cs typeface="Arial"/>
               </a:rPr>
-              <a:t>سياسة القرار: الضابطة، العزل الكامل، القاعدة البسيطة، ACRS.</a:t>
+              <a:t>طريقة الحماية: بدون حماية، أو قطع كل شي، أو قاعدة بسيطة، أو ACRS</a:t>
             </a:r>
           </a:p>
           <a:p>
@@ -5367,24 +5367,24 @@
               </a:spcAft>
             </a:pPr>
             <a:r>
-              <a:rPr sz="1400" b="1" lang="ar-SA">
+              <a:rPr sz="1300" b="1" lang="ar-SA">
                 <a:solidFill>
                   <a:srgbClr val="1C2328"/>
                 </a:solidFill>
                 <a:latin typeface="Arial"/>
                 <a:cs typeface="Arial"/>
               </a:rPr>
-              <a:t>التابع: </a:t>
-            </a:r>
-            <a:r>
-              <a:rPr sz="1400" b="0" lang="ar-SA">
+              <a:t>اللي نقيسه: </a:t>
+            </a:r>
+            <a:r>
+              <a:rPr sz="1300" b="0" lang="ar-SA">
                 <a:solidFill>
                   <a:srgbClr val="1C2328"/>
                 </a:solidFill>
                 <a:latin typeface="Arial"/>
                 <a:cs typeface="Arial"/>
               </a:rPr>
-              <a:t>الاحتواء، الخدمات المتوقفة، السلامة، الزمن.</a:t>
+              <a:t>وقف المخترق؟ كم خدمة تعطّلت؟ القرار آمن؟ الوقت.</a:t>
             </a:r>
           </a:p>
           <a:p>
@@ -5394,24 +5394,24 @@
               </a:spcAft>
             </a:pPr>
             <a:r>
-              <a:rPr sz="1400" b="1" lang="ar-SA">
+              <a:rPr sz="1300" b="1" lang="ar-SA">
                 <a:solidFill>
                   <a:srgbClr val="1C2328"/>
                 </a:solidFill>
                 <a:latin typeface="Arial"/>
                 <a:cs typeface="Arial"/>
               </a:rPr>
-              <a:t>الضابط: </a:t>
-            </a:r>
-            <a:r>
-              <a:rPr sz="1400" b="0" lang="ar-SA">
+              <a:t>اللي نثبّته: </a:t>
+            </a:r>
+            <a:r>
+              <a:rPr sz="1300" b="0" lang="ar-SA">
                 <a:solidFill>
                   <a:srgbClr val="1C2328"/>
                 </a:solidFill>
                 <a:latin typeface="Arial"/>
                 <a:cs typeface="Arial"/>
               </a:rPr>
-              <a:t>الأوزان، والعتبة 7، والبذور.</a:t>
+              <a:t>نفس الهجمات ونفس الإعدادات للكل.</a:t>
             </a:r>
           </a:p>
         </p:txBody>
@@ -5847,7 +5847,7 @@
                 <a:latin typeface="Arial"/>
                 <a:cs typeface="Arial"/>
               </a:rPr>
-              <a:t>المجموعات التجريبية على نفس الهجمات:</a:t>
+              <a:t>جرّبنا كل الطرق على نفس الهجمات:</a:t>
             </a:r>
           </a:p>
           <a:p>
@@ -5874,7 +5874,7 @@
                 <a:latin typeface="Arial"/>
                 <a:cs typeface="Arial"/>
               </a:rPr>
-              <a:t>بلا حماية: 23 مسارًا مفتوحًا إلى خوادم حرجة</a:t>
+              <a:t>بدون حماية: المخترق يوصل لأجهزة مهمة من 23 طريق</a:t>
             </a:r>
           </a:p>
           <a:p>
@@ -5901,7 +5901,7 @@
                 <a:latin typeface="Arial"/>
                 <a:cs typeface="Arial"/>
               </a:rPr>
-              <a:t>محاكاة: 4,000+ سيناريو تركيبي و894 واقعي</a:t>
+              <a:t>محاكاة: أكثر من 4,000 هجوم، و894 لحظة تشبه الواقع</a:t>
             </a:r>
           </a:p>
           <a:p>
@@ -5928,7 +5928,7 @@
                 <a:latin typeface="Arial"/>
                 <a:cs typeface="Arial"/>
               </a:rPr>
-              <a:t>نواة Linux: نفس القواعد تُختبر حاسوبيًا ثم فعليًا (66/66)</a:t>
+              <a:t>كمبيوتر Linux حقيقي: نفّذ القرارات صح 66 من 66</a:t>
             </a:r>
           </a:p>
           <a:p>
@@ -5955,7 +5955,7 @@
                 <a:latin typeface="Arial"/>
                 <a:cs typeface="Arial"/>
               </a:rPr>
-              <a:t>كمّي: 3 حواسيب IBM، الأمثل 11/11</a:t>
+              <a:t>حاسوب كمّي (IBM): لقى أفضل حل 11 من 11</a:t>
             </a:r>
           </a:p>
           <a:p>
@@ -5982,7 +5982,7 @@
                 <a:latin typeface="Arial"/>
                 <a:cs typeface="Arial"/>
               </a:rPr>
-              <a:t>الابتكار: 83 حادثة حقيقية 2013–2026</a:t>
+              <a:t>83 اختراق حقيقي صار في العالم 2013–2026</a:t>
             </a:r>
           </a:p>
         </p:txBody>
@@ -6411,24 +6411,24 @@
               </a:defRPr>
             </a:pPr>
             <a:r>
-              <a:rPr sz="1100" b="1" lang="ar-SA">
+              <a:rPr sz="1400" b="1" lang="ar-SA">
                 <a:solidFill>
                   <a:srgbClr val="1C2328"/>
                 </a:solidFill>
                 <a:latin typeface="Arial"/>
                 <a:cs typeface="Arial"/>
               </a:rPr>
-              <a:t>نوتة الحمل: </a:t>
-            </a:r>
-            <a:r>
-              <a:rPr sz="1100" b="0" lang="ar-SA">
+              <a:t>اختبار الضغط: </a:t>
+            </a:r>
+            <a:r>
+              <a:rPr sz="1400" b="0" lang="ar-SA">
                 <a:solidFill>
                   <a:srgbClr val="1C2328"/>
                 </a:solidFill>
                 <a:latin typeface="Arial"/>
                 <a:cs typeface="Arial"/>
               </a:rPr>
-              <a:t>1,000 جهاز ← 2.3 مللي ثانية · 1,000 تنبيه دفعة ← 0.7 ثانية · Wilson وMcNemar وWilcoxon</a:t>
+              <a:t>شبكة فيها 1,000 جهاز ← القرار في أقل من 3 أجزاء من الألف من الثانية · 1,000 تنبيه مرة وحدة ← 0.7 ثانية</a:t>
             </a:r>
           </a:p>
         </p:txBody>
@@ -6670,7 +6670,7 @@
                 </a:solidFill>
                 <a:latin typeface="Arial"/>
               </a:rPr>
-              <a:t>يوقف المهاجم بأقل إجراء آمن… ويُبقي الخدمات تعمل</a:t>
+              <a:t>يوقف المخترق بأصغر خطوة آمنة… والخدمات تبقى شغّالة</a:t>
             </a:r>
           </a:p>
         </p:txBody>

</xml_diff>

<commit_message>
Board v6: ACRS Box logo in the title, richer boxes (breakout time, fault test, restart result), source added
Co-Authored-By: Claude Opus 5.5 <noreply@anthropic.com>
Claude-Session: https://claude.ai/code/session_013B4LPWZWgdrx1XoL9LPLxx
</commit_message>
<xml_diff>
--- a/docs/qacrs/board/ACRS_board.pptx
+++ b/docs/qacrs/board/ACRS_board.pptx
@@ -2683,8 +2683,8 @@
         </p:nvSpPr>
         <p:spPr>
           <a:xfrm>
-            <a:off x="2428875" y="2930000"/>
-            <a:ext cx="7639050" cy="1380000"/>
+            <a:off x="3345500" y="2930000"/>
+            <a:ext cx="6955800" cy="1380000"/>
           </a:xfrm>
           <a:prstGeom prst="rect">
             <a:avLst/>
@@ -2732,7 +2732,7 @@
               <a:t>ACRS</a:t>
             </a:r>
             <a:r>
-              <a:rPr sz="2200" b="1">
+              <a:rPr sz="1700" b="1">
                 <a:solidFill>
                   <a:srgbClr val="FFFFFF"/>
                 </a:solidFill>
@@ -3293,7 +3293,7 @@
           <a:p>
             <a:pPr algn="r" rtl="1">
               <a:spcAft>
-                <a:spcPts val="100"/>
+                <a:spcPts val="0"/>
               </a:spcAft>
               <a:defRPr sz="1500" b="0">
                 <a:solidFill>
@@ -3305,7 +3305,7 @@
               </a:defRPr>
             </a:pPr>
             <a:r>
-              <a:rPr sz="2000" b="1" lang="ar-SA">
+              <a:rPr sz="1800" b="1" lang="ar-SA">
                 <a:solidFill>
                   <a:srgbClr val="008A58"/>
                 </a:solidFill>
@@ -3315,7 +3315,7 @@
               <a:t>91%  </a:t>
             </a:r>
             <a:r>
-              <a:rPr sz="1300" b="0" lang="ar-SA">
+              <a:rPr sz="1200" b="0" lang="ar-SA">
                 <a:solidFill>
                   <a:srgbClr val="1C2328"/>
                 </a:solidFill>
@@ -3328,11 +3328,11 @@
           <a:p>
             <a:pPr algn="r" rtl="1">
               <a:spcAft>
-                <a:spcPts val="100"/>
+                <a:spcPts val="0"/>
               </a:spcAft>
             </a:pPr>
             <a:r>
-              <a:rPr sz="2000" b="1" lang="ar-SA">
+              <a:rPr sz="1800" b="1" lang="ar-SA">
                 <a:solidFill>
                   <a:srgbClr val="008A58"/>
                 </a:solidFill>
@@ -3342,7 +3342,7 @@
               <a:t>70  </a:t>
             </a:r>
             <a:r>
-              <a:rPr sz="1300" b="0" lang="ar-SA">
+              <a:rPr sz="1200" b="0" lang="ar-SA">
                 <a:solidFill>
                   <a:srgbClr val="1C2328"/>
                 </a:solidFill>
@@ -3355,11 +3355,11 @@
           <a:p>
             <a:pPr algn="r" rtl="1">
               <a:spcAft>
-                <a:spcPts val="100"/>
+                <a:spcPts val="0"/>
               </a:spcAft>
             </a:pPr>
             <a:r>
-              <a:rPr sz="2000" b="1" lang="ar-SA">
+              <a:rPr sz="1800" b="1" lang="ar-SA">
                 <a:solidFill>
                   <a:srgbClr val="008A58"/>
                 </a:solidFill>
@@ -3369,7 +3369,7 @@
               <a:t>0  </a:t>
             </a:r>
             <a:r>
-              <a:rPr sz="1300" b="0" lang="ar-SA">
+              <a:rPr sz="1200" b="0" lang="ar-SA">
                 <a:solidFill>
                   <a:srgbClr val="1C2328"/>
                 </a:solidFill>
@@ -3382,11 +3382,11 @@
           <a:p>
             <a:pPr algn="r" rtl="1">
               <a:spcAft>
-                <a:spcPts val="100"/>
+                <a:spcPts val="0"/>
               </a:spcAft>
             </a:pPr>
             <a:r>
-              <a:rPr sz="2000" b="1" lang="ar-SA">
+              <a:rPr sz="1800" b="1" lang="ar-SA">
                 <a:solidFill>
                   <a:srgbClr val="008A58"/>
                 </a:solidFill>
@@ -3396,7 +3396,7 @@
               <a:t>11/11  </a:t>
             </a:r>
             <a:r>
-              <a:rPr sz="1300" b="0" lang="ar-SA">
+              <a:rPr sz="1200" b="0" lang="ar-SA">
                 <a:solidFill>
                   <a:srgbClr val="1C2328"/>
                 </a:solidFill>
@@ -3404,6 +3404,33 @@
                 <a:cs typeface="Arial"/>
               </a:rPr>
               <a:t>أفضل حل كمّي</a:t>
+            </a:r>
+          </a:p>
+          <a:p>
+            <a:pPr algn="r" rtl="1">
+              <a:spcAft>
+                <a:spcPts val="0"/>
+              </a:spcAft>
+            </a:pPr>
+            <a:r>
+              <a:rPr sz="1800" b="1" lang="ar-SA">
+                <a:solidFill>
+                  <a:srgbClr val="008A58"/>
+                </a:solidFill>
+                <a:latin typeface="Arial"/>
+                <a:cs typeface="Arial"/>
+              </a:rPr>
+              <a:t>0  </a:t>
+            </a:r>
+            <a:r>
+              <a:rPr sz="1200" b="0" lang="ar-SA">
+                <a:solidFill>
+                  <a:srgbClr val="1C2328"/>
+                </a:solidFill>
+                <a:latin typeface="Arial"/>
+                <a:cs typeface="Arial"/>
+              </a:rPr>
+              <a:t>جهاز رجع بعد 200 إعادة تشغيل</a:t>
             </a:r>
           </a:p>
         </p:txBody>
@@ -3588,7 +3615,7 @@
               </a:defRPr>
             </a:pPr>
             <a:r>
-              <a:rPr sz="1300" b="0" lang="ar-SA">
+              <a:rPr sz="1200" b="0" lang="ar-SA">
                 <a:solidFill>
                   <a:srgbClr val="1C2328"/>
                 </a:solidFill>
@@ -3605,7 +3632,7 @@
               </a:spcAft>
             </a:pPr>
             <a:r>
-              <a:rPr sz="1300" b="1" lang="ar-SA">
+              <a:rPr sz="1200" b="1" lang="ar-SA">
                 <a:solidFill>
                   <a:srgbClr val="1C2328"/>
                 </a:solidFill>
@@ -3615,7 +3642,7 @@
               <a:t>مثال HSE (مستشفيات إيرلندا): </a:t>
             </a:r>
             <a:r>
-              <a:rPr sz="1300" b="0" lang="ar-SA">
+              <a:rPr sz="1200" b="0" lang="ar-SA">
                 <a:solidFill>
                   <a:srgbClr val="1C2328"/>
                 </a:solidFill>
@@ -4208,7 +4235,7 @@
               </a:defRPr>
             </a:pPr>
             <a:r>
-              <a:rPr sz="1300" b="0" lang="ar-SA">
+              <a:rPr sz="1200" b="0" lang="ar-SA">
                 <a:solidFill>
                   <a:srgbClr val="1C2328"/>
                 </a:solidFill>
@@ -4225,7 +4252,7 @@
               </a:spcAft>
             </a:pPr>
             <a:r>
-              <a:rPr sz="1300" b="0" lang="ar-SA">
+              <a:rPr sz="1200" b="0" lang="ar-SA">
                 <a:solidFill>
                   <a:srgbClr val="1C2328"/>
                 </a:solidFill>
@@ -4242,7 +4269,7 @@
               </a:spcAft>
             </a:pPr>
             <a:r>
-              <a:rPr sz="1300" b="0" lang="ar-SA">
+              <a:rPr sz="1200" b="0" lang="ar-SA">
                 <a:solidFill>
                   <a:srgbClr val="1C2328"/>
                 </a:solidFill>
@@ -4259,7 +4286,7 @@
               </a:spcAft>
             </a:pPr>
             <a:r>
-              <a:rPr sz="1300" b="0" lang="ar-SA">
+              <a:rPr sz="1200" b="0" lang="ar-SA">
                 <a:solidFill>
                   <a:srgbClr val="1C2328"/>
                 </a:solidFill>
@@ -4267,6 +4294,23 @@
                 <a:cs typeface="Arial"/>
               </a:rPr>
               <a:t>MITRE (2024). Attack Flow corpus.</a:t>
+            </a:r>
+          </a:p>
+          <a:p>
+            <a:pPr algn="l" rtl="0">
+              <a:spcAft>
+                <a:spcPts val="300"/>
+              </a:spcAft>
+            </a:pPr>
+            <a:r>
+              <a:rPr sz="1200" b="0" lang="ar-SA">
+                <a:solidFill>
+                  <a:srgbClr val="1C2328"/>
+                </a:solidFill>
+                <a:latin typeface="Arial"/>
+                <a:cs typeface="Arial"/>
+              </a:rPr>
+              <a:t>CrowdStrike (2026). Global Threat Report.</a:t>
             </a:r>
           </a:p>
         </p:txBody>
@@ -4451,7 +4495,7 @@
               </a:defRPr>
             </a:pPr>
             <a:r>
-              <a:rPr sz="1400" b="0" lang="ar-SA">
+              <a:rPr sz="1300" b="0" lang="ar-SA">
                 <a:solidFill>
                   <a:srgbClr val="1C2328"/>
                 </a:solidFill>
@@ -4468,7 +4512,7 @@
               </a:spcAft>
             </a:pPr>
             <a:r>
-              <a:rPr sz="1400" b="0" lang="ar-SA">
+              <a:rPr sz="1300" b="0" lang="ar-SA">
                 <a:solidFill>
                   <a:srgbClr val="1C2328"/>
                 </a:solidFill>
@@ -4478,7 +4522,7 @@
               <a:t>في هجوم WannaCry تعطّلت </a:t>
             </a:r>
             <a:r>
-              <a:rPr sz="1400" b="1" lang="ar-SA">
+              <a:rPr sz="1300" b="1" lang="ar-SA">
                 <a:solidFill>
                   <a:srgbClr val="1C2328"/>
                 </a:solidFill>
@@ -4488,7 +4532,7 @@
               <a:t>46 جهة صحية</a:t>
             </a:r>
             <a:r>
-              <a:rPr sz="1400" b="0" lang="ar-SA">
+              <a:rPr sz="1300" b="0" lang="ar-SA">
                 <a:solidFill>
                   <a:srgbClr val="1C2328"/>
                 </a:solidFill>
@@ -4496,6 +4540,43 @@
                 <a:cs typeface="Arial"/>
               </a:rPr>
               <a:t> ما وصلها الهجوم أصلًا.</a:t>
+            </a:r>
+          </a:p>
+          <a:p>
+            <a:pPr algn="r" rtl="1">
+              <a:spcAft>
+                <a:spcPts val="300"/>
+              </a:spcAft>
+            </a:pPr>
+            <a:r>
+              <a:rPr sz="1300" b="0" lang="ar-SA">
+                <a:solidFill>
+                  <a:srgbClr val="1C2328"/>
+                </a:solidFill>
+                <a:latin typeface="Arial"/>
+                <a:cs typeface="Arial"/>
+              </a:rPr>
+              <a:t>والمخترق ينتقل بين الأجهزة في </a:t>
+            </a:r>
+            <a:r>
+              <a:rPr sz="1300" b="1" lang="ar-SA">
+                <a:solidFill>
+                  <a:srgbClr val="1C2328"/>
+                </a:solidFill>
+                <a:latin typeface="Arial"/>
+                <a:cs typeface="Arial"/>
+              </a:rPr>
+              <a:t>29 دقيقة</a:t>
+            </a:r>
+            <a:r>
+              <a:rPr sz="1300" b="0" lang="ar-SA">
+                <a:solidFill>
+                  <a:srgbClr val="1C2328"/>
+                </a:solidFill>
+                <a:latin typeface="Arial"/>
+                <a:cs typeface="Arial"/>
+              </a:rPr>
+              <a:t> بالمتوسط، وأسرعها 27 ثانية.</a:t>
             </a:r>
           </a:p>
         </p:txBody>
@@ -4680,7 +4761,7 @@
               </a:defRPr>
             </a:pPr>
             <a:r>
-              <a:rPr sz="1400" b="0" lang="ar-SA">
+              <a:rPr sz="1300" b="0" lang="ar-SA">
                 <a:solidFill>
                   <a:srgbClr val="1C2328"/>
                 </a:solidFill>
@@ -4697,7 +4778,7 @@
               </a:spcAft>
             </a:pPr>
             <a:r>
-              <a:rPr sz="1400" b="1" lang="ar-SA">
+              <a:rPr sz="1300" b="1" lang="ar-SA">
                 <a:solidFill>
                   <a:srgbClr val="1C2328"/>
                 </a:solidFill>
@@ -4707,14 +4788,51 @@
               <a:t>بدون كسر أي قاعدة أمان</a:t>
             </a:r>
             <a:r>
-              <a:rPr sz="1400" b="0" lang="ar-SA">
+              <a:rPr sz="1300" b="0" lang="ar-SA">
                 <a:solidFill>
                   <a:srgbClr val="1C2328"/>
                 </a:solidFill>
                 <a:latin typeface="Arial"/>
                 <a:cs typeface="Arial"/>
               </a:rPr>
-              <a:t>، وكل قرار يقدر أحد يراجعه.</a:t>
+              <a:t>، وكل قرار موقّع يقدر أحد يراجعه.</a:t>
+            </a:r>
+          </a:p>
+          <a:p>
+            <a:pPr algn="r" rtl="1">
+              <a:spcAft>
+                <a:spcPts val="300"/>
+              </a:spcAft>
+            </a:pPr>
+            <a:r>
+              <a:rPr sz="1300" b="0" lang="ar-SA">
+                <a:solidFill>
+                  <a:srgbClr val="1C2328"/>
+                </a:solidFill>
+                <a:latin typeface="Arial"/>
+                <a:cs typeface="Arial"/>
+              </a:rPr>
+              <a:t>والقرار أسرع من المخترق: </a:t>
+            </a:r>
+            <a:r>
+              <a:rPr sz="1300" b="1" lang="ar-SA">
+                <a:solidFill>
+                  <a:srgbClr val="1C2328"/>
+                </a:solidFill>
+                <a:latin typeface="Arial"/>
+                <a:cs typeface="Arial"/>
+              </a:rPr>
+              <a:t>أجزاء من الألف من الثانية</a:t>
+            </a:r>
+            <a:r>
+              <a:rPr sz="1300" b="0" lang="ar-SA">
+                <a:solidFill>
+                  <a:srgbClr val="1C2328"/>
+                </a:solidFill>
+                <a:latin typeface="Arial"/>
+                <a:cs typeface="Arial"/>
+              </a:rPr>
+              <a:t>.</a:t>
             </a:r>
           </a:p>
         </p:txBody>
@@ -4899,14 +5017,14 @@
               </a:defRPr>
             </a:pPr>
             <a:r>
-              <a:rPr sz="1300" b="0" lang="ar-SA">
+              <a:rPr sz="1200" b="0" lang="ar-SA">
                 <a:solidFill>
                   <a:srgbClr val="1C2328"/>
                 </a:solidFill>
                 <a:latin typeface="Arial"/>
                 <a:cs typeface="Arial"/>
               </a:rPr>
-              <a:t>النظام يحل القرار مثل لغز: يوازن الخيارات ويختار الأفضل، على كمبيوتر عادي وعلى حاسوب كمّي من IBM.</a:t>
+              <a:t>النظام يحل القرار مثل لغز: يوازن الخيارات ويختار الأفضل، على كمبيوتر عادي وحاسوب كمّي (IBM)، ويعتمد على قائمة MITRE لطرق المخترقين.</a:t>
             </a:r>
           </a:p>
         </p:txBody>
@@ -6411,7 +6529,7 @@
               </a:defRPr>
             </a:pPr>
             <a:r>
-              <a:rPr sz="1400" b="1" lang="ar-SA">
+              <a:rPr sz="1100" b="1" lang="ar-SA">
                 <a:solidFill>
                   <a:srgbClr val="1C2328"/>
                 </a:solidFill>
@@ -6421,14 +6539,41 @@
               <a:t>اختبار الضغط: </a:t>
             </a:r>
             <a:r>
-              <a:rPr sz="1400" b="0" lang="ar-SA">
+              <a:rPr sz="1100" b="0" lang="ar-SA">
                 <a:solidFill>
                   <a:srgbClr val="1C2328"/>
                 </a:solidFill>
                 <a:latin typeface="Arial"/>
                 <a:cs typeface="Arial"/>
               </a:rPr>
-              <a:t>شبكة فيها 1,000 جهاز ← القرار في أقل من 3 أجزاء من الألف من الثانية · 1,000 تنبيه مرة وحدة ← 0.7 ثانية</a:t>
+              <a:t>1,000 جهاز ← قرار في أقل من 3 أجزاء من الألف من الثانية · 1,000 تنبيه ← 0.7 ث</a:t>
+            </a:r>
+          </a:p>
+          <a:p>
+            <a:pPr algn="r" rtl="1">
+              <a:spcAft>
+                <a:spcPts val="300"/>
+              </a:spcAft>
+            </a:pPr>
+            <a:r>
+              <a:rPr sz="1100" b="1" lang="ar-SA">
+                <a:solidFill>
+                  <a:srgbClr val="1C2328"/>
+                </a:solidFill>
+                <a:latin typeface="Arial"/>
+                <a:cs typeface="Arial"/>
+              </a:rPr>
+              <a:t>اختبار العطل: </a:t>
+            </a:r>
+            <a:r>
+              <a:rPr sz="1100" b="0" lang="ar-SA">
+                <a:solidFill>
+                  <a:srgbClr val="1C2328"/>
+                </a:solidFill>
+                <a:latin typeface="Arial"/>
+                <a:cs typeface="Arial"/>
+              </a:rPr>
+              <a:t>354 عطلًا محقونًا ← 0 قرار خطير · 200 إعادة تشغيل ← 0 جهاز رجع</a:t>
             </a:r>
           </a:p>
         </p:txBody>
@@ -6677,7 +6822,7 @@
       </p:sp>
       <p:pic>
         <p:nvPicPr>
-          <p:cNvPr id="64" name="Picture 63" descr="pipe.png"/>
+          <p:cNvPr id="64" name="Picture 63" descr="logo.png"/>
           <p:cNvPicPr>
             <a:picLocks noChangeAspect="1"/>
           </p:cNvPicPr>
@@ -6691,8 +6836,8 @@
         </p:blipFill>
         <p:spPr>
           <a:xfrm>
-            <a:off x="3469475" y="6573345"/>
-            <a:ext cx="5529275" cy="2064262"/>
+            <a:off x="2355500" y="3301300"/>
+            <a:ext cx="1100000" cy="1000000"/>
           </a:xfrm>
           <a:prstGeom prst="rect">
             <a:avLst/>
@@ -6701,7 +6846,7 @@
       </p:pic>
       <p:pic>
         <p:nvPicPr>
-          <p:cNvPr id="65" name="Picture 64" descr="chart.png"/>
+          <p:cNvPr id="65" name="Picture 64" descr="pipe.png"/>
           <p:cNvPicPr>
             <a:picLocks noChangeAspect="1"/>
           </p:cNvPicPr>
@@ -6709,6 +6854,30 @@
         </p:nvPicPr>
         <p:blipFill>
           <a:blip r:embed="rId6"/>
+          <a:stretch>
+            <a:fillRect/>
+          </a:stretch>
+        </p:blipFill>
+        <p:spPr>
+          <a:xfrm>
+            <a:off x="3469475" y="6573345"/>
+            <a:ext cx="5529275" cy="2064262"/>
+          </a:xfrm>
+          <a:prstGeom prst="rect">
+            <a:avLst/>
+          </a:prstGeom>
+        </p:spPr>
+      </p:pic>
+      <p:pic>
+        <p:nvPicPr>
+          <p:cNvPr id="66" name="Picture 65" descr="chart.png"/>
+          <p:cNvPicPr>
+            <a:picLocks noChangeAspect="1"/>
+          </p:cNvPicPr>
+          <p:nvPr/>
+        </p:nvPicPr>
+        <p:blipFill>
+          <a:blip r:embed="rId7"/>
           <a:stretch>
             <a:fillRect/>
           </a:stretch>

</xml_diff>